<commit_message>
Enhance presentation with 4 new visual slides (process flow, dashboard UI, agent interaction, assessment results)
</commit_message>
<xml_diff>
--- a/docs/Insurance_Claim_Assessment_Presentation.pptx
+++ b/docs/Insurance_Claim_Assessment_Presentation.pptx
@@ -29,6 +29,10 @@
     <p:sldId id="277" r:id="rId28"/>
     <p:sldId id="278" r:id="rId29"/>
     <p:sldId id="279" r:id="rId30"/>
+    <p:sldId id="280" r:id="rId31"/>
+    <p:sldId id="281" r:id="rId32"/>
+    <p:sldId id="282" r:id="rId33"/>
+    <p:sldId id="283" r:id="rId34"/>
   </p:sldIdLst>
   <p:sldSz cx="9144000" cy="6858000" type="screen4x3"/>
   <p:notesSz cx="6858000" cy="9144000"/>
@@ -9449,6 +9453,1979 @@
 </file>
 
 <file path=ppt/slides/slide24.xml><?xml version="1.0" encoding="utf-8"?>
+<p:sld xmlns:a="http://schemas.openxmlformats.org/drawingml/2006/main" xmlns:p="http://schemas.openxmlformats.org/presentationml/2006/main" xmlns:r="http://schemas.openxmlformats.org/officeDocument/2006/relationships">
+  <p:cSld>
+    <p:bg>
+      <p:bgPr>
+        <a:solidFill>
+          <a:srgbClr val="FFFFFF"/>
+        </a:solidFill>
+        <a:effectLst/>
+      </p:bgPr>
+    </p:bg>
+    <p:spTree>
+      <p:nvGrpSpPr>
+        <p:cNvPr id="1" name=""/>
+        <p:cNvGrpSpPr/>
+        <p:nvPr/>
+      </p:nvGrpSpPr>
+      <p:grpSpPr/>
+      <p:sp>
+        <p:nvSpPr>
+          <p:cNvPr id="2" name="Rectangle 1"/>
+          <p:cNvSpPr/>
+          <p:nvPr/>
+        </p:nvSpPr>
+        <p:spPr>
+          <a:xfrm>
+            <a:off x="0" y="0"/>
+            <a:ext cx="9144000" cy="731520"/>
+          </a:xfrm>
+          <a:prstGeom prst="rect">
+            <a:avLst/>
+          </a:prstGeom>
+          <a:solidFill>
+            <a:srgbClr val="19376D"/>
+          </a:solidFill>
+          <a:ln>
+            <a:solidFill>
+              <a:srgbClr val="19376D"/>
+            </a:solidFill>
+          </a:ln>
+        </p:spPr>
+        <p:style>
+          <a:lnRef idx="1">
+            <a:schemeClr val="accent1"/>
+          </a:lnRef>
+          <a:fillRef idx="3">
+            <a:schemeClr val="accent1"/>
+          </a:fillRef>
+          <a:effectRef idx="2">
+            <a:schemeClr val="accent1"/>
+          </a:effectRef>
+          <a:fontRef idx="minor">
+            <a:schemeClr val="lt1"/>
+          </a:fontRef>
+        </p:style>
+        <p:txBody>
+          <a:bodyPr rtlCol="0" anchor="ctr"/>
+          <a:lstStyle/>
+          <a:p>
+            <a:pPr algn="ctr"/>
+          </a:p>
+        </p:txBody>
+      </p:sp>
+      <p:sp>
+        <p:nvSpPr>
+          <p:cNvPr id="3" name="TextBox 2"/>
+          <p:cNvSpPr txBox="1"/>
+          <p:nvPr/>
+        </p:nvSpPr>
+        <p:spPr>
+          <a:xfrm>
+            <a:off x="457200" y="137160"/>
+            <a:ext cx="8229600" cy="548640"/>
+          </a:xfrm>
+          <a:prstGeom prst="rect">
+            <a:avLst/>
+          </a:prstGeom>
+          <a:noFill/>
+        </p:spPr>
+        <p:txBody>
+          <a:bodyPr wrap="none">
+            <a:spAutoFit/>
+          </a:bodyPr>
+          <a:lstStyle/>
+          <a:p>
+            <a:pPr>
+              <a:defRPr sz="3200" b="1">
+                <a:solidFill>
+                  <a:srgbClr val="FFFFFF"/>
+                </a:solidFill>
+              </a:defRPr>
+            </a:pPr>
+            <a:r>
+              <a:t>Slide 24: Assessment Pipeline - Visual Flow</a:t>
+            </a:r>
+          </a:p>
+        </p:txBody>
+      </p:sp>
+      <p:sp>
+        <p:nvSpPr>
+          <p:cNvPr id="4" name="Rounded Rectangle 3"/>
+          <p:cNvSpPr/>
+          <p:nvPr/>
+        </p:nvSpPr>
+        <p:spPr>
+          <a:xfrm>
+            <a:off x="274320" y="1828800"/>
+            <a:ext cx="822960" cy="548640"/>
+          </a:xfrm>
+          <a:prstGeom prst="roundRect">
+            <a:avLst/>
+          </a:prstGeom>
+          <a:solidFill>
+            <a:srgbClr val="FF7F27"/>
+          </a:solidFill>
+          <a:ln>
+            <a:solidFill>
+              <a:srgbClr val="19376D"/>
+            </a:solidFill>
+          </a:ln>
+        </p:spPr>
+        <p:style>
+          <a:lnRef idx="1">
+            <a:schemeClr val="accent1"/>
+          </a:lnRef>
+          <a:fillRef idx="3">
+            <a:schemeClr val="accent1"/>
+          </a:fillRef>
+          <a:effectRef idx="2">
+            <a:schemeClr val="accent1"/>
+          </a:effectRef>
+          <a:fontRef idx="minor">
+            <a:schemeClr val="lt1"/>
+          </a:fontRef>
+        </p:style>
+        <p:txBody>
+          <a:bodyPr rtlCol="0" anchor="ctr"/>
+          <a:lstStyle/>
+          <a:p>
+            <a:pPr algn="ctr">
+              <a:defRPr sz="900" b="1">
+                <a:solidFill>
+                  <a:srgbClr val="FFFFFF"/>
+                </a:solidFill>
+              </a:defRPr>
+            </a:pPr>
+            <a:r>
+              <a:t>INPUT</a:t>
+            </a:r>
+          </a:p>
+        </p:txBody>
+      </p:sp>
+      <p:cxnSp>
+        <p:nvCxnSpPr>
+          <p:cNvPr id="5" name="Connector 4"/>
+          <p:cNvCxnSpPr/>
+          <p:nvPr/>
+        </p:nvCxnSpPr>
+        <p:spPr>
+          <a:xfrm>
+            <a:off x="1097280" y="2103120.0"/>
+            <a:ext cx="137160" cy="0.0"/>
+          </a:xfrm>
+          <a:prstGeom prst="line">
+            <a:avLst/>
+          </a:prstGeom>
+          <a:ln>
+            <a:solidFill>
+              <a:srgbClr val="404040"/>
+            </a:solidFill>
+          </a:ln>
+        </p:spPr>
+        <p:style>
+          <a:lnRef idx="2">
+            <a:schemeClr val="accent1"/>
+          </a:lnRef>
+          <a:fillRef idx="0">
+            <a:schemeClr val="accent1"/>
+          </a:fillRef>
+          <a:effectRef idx="1">
+            <a:schemeClr val="accent1"/>
+          </a:effectRef>
+          <a:fontRef idx="minor">
+            <a:schemeClr val="tx1"/>
+          </a:fontRef>
+        </p:style>
+      </p:cxnSp>
+      <p:sp>
+        <p:nvSpPr>
+          <p:cNvPr id="6" name="Rounded Rectangle 5"/>
+          <p:cNvSpPr/>
+          <p:nvPr/>
+        </p:nvSpPr>
+        <p:spPr>
+          <a:xfrm>
+            <a:off x="1234440" y="1828800"/>
+            <a:ext cx="822960" cy="548640"/>
+          </a:xfrm>
+          <a:prstGeom prst="roundRect">
+            <a:avLst/>
+          </a:prstGeom>
+          <a:solidFill>
+            <a:srgbClr val="3B5998"/>
+          </a:solidFill>
+          <a:ln>
+            <a:solidFill>
+              <a:srgbClr val="19376D"/>
+            </a:solidFill>
+          </a:ln>
+        </p:spPr>
+        <p:style>
+          <a:lnRef idx="1">
+            <a:schemeClr val="accent1"/>
+          </a:lnRef>
+          <a:fillRef idx="3">
+            <a:schemeClr val="accent1"/>
+          </a:fillRef>
+          <a:effectRef idx="2">
+            <a:schemeClr val="accent1"/>
+          </a:effectRef>
+          <a:fontRef idx="minor">
+            <a:schemeClr val="lt1"/>
+          </a:fontRef>
+        </p:style>
+        <p:txBody>
+          <a:bodyPr rtlCol="0" anchor="ctr"/>
+          <a:lstStyle/>
+          <a:p>
+            <a:pPr algn="ctr">
+              <a:defRPr sz="900" b="1">
+                <a:solidFill>
+                  <a:srgbClr val="FFFFFF"/>
+                </a:solidFill>
+              </a:defRPr>
+            </a:pPr>
+            <a:r>
+              <a:t>Validation</a:t>
+            </a:r>
+          </a:p>
+        </p:txBody>
+      </p:sp>
+      <p:cxnSp>
+        <p:nvCxnSpPr>
+          <p:cNvPr id="7" name="Connector 6"/>
+          <p:cNvCxnSpPr/>
+          <p:nvPr/>
+        </p:nvCxnSpPr>
+        <p:spPr>
+          <a:xfrm>
+            <a:off x="2057400" y="2103120.0"/>
+            <a:ext cx="137160" cy="0.0"/>
+          </a:xfrm>
+          <a:prstGeom prst="line">
+            <a:avLst/>
+          </a:prstGeom>
+          <a:ln>
+            <a:solidFill>
+              <a:srgbClr val="404040"/>
+            </a:solidFill>
+          </a:ln>
+        </p:spPr>
+        <p:style>
+          <a:lnRef idx="2">
+            <a:schemeClr val="accent1"/>
+          </a:lnRef>
+          <a:fillRef idx="0">
+            <a:schemeClr val="accent1"/>
+          </a:fillRef>
+          <a:effectRef idx="1">
+            <a:schemeClr val="accent1"/>
+          </a:effectRef>
+          <a:fontRef idx="minor">
+            <a:schemeClr val="tx1"/>
+          </a:fontRef>
+        </p:style>
+      </p:cxnSp>
+      <p:sp>
+        <p:nvSpPr>
+          <p:cNvPr id="8" name="Rounded Rectangle 7"/>
+          <p:cNvSpPr/>
+          <p:nvPr/>
+        </p:nvSpPr>
+        <p:spPr>
+          <a:xfrm>
+            <a:off x="2194560" y="1828800"/>
+            <a:ext cx="822960" cy="548640"/>
+          </a:xfrm>
+          <a:prstGeom prst="roundRect">
+            <a:avLst/>
+          </a:prstGeom>
+          <a:solidFill>
+            <a:srgbClr val="3B5998"/>
+          </a:solidFill>
+          <a:ln>
+            <a:solidFill>
+              <a:srgbClr val="19376D"/>
+            </a:solidFill>
+          </a:ln>
+        </p:spPr>
+        <p:style>
+          <a:lnRef idx="1">
+            <a:schemeClr val="accent1"/>
+          </a:lnRef>
+          <a:fillRef idx="3">
+            <a:schemeClr val="accent1"/>
+          </a:fillRef>
+          <a:effectRef idx="2">
+            <a:schemeClr val="accent1"/>
+          </a:effectRef>
+          <a:fontRef idx="minor">
+            <a:schemeClr val="lt1"/>
+          </a:fontRef>
+        </p:style>
+        <p:txBody>
+          <a:bodyPr rtlCol="0" anchor="ctr"/>
+          <a:lstStyle/>
+          <a:p>
+            <a:pPr algn="ctr">
+              <a:defRPr sz="900" b="1">
+                <a:solidFill>
+                  <a:srgbClr val="FFFFFF"/>
+                </a:solidFill>
+              </a:defRPr>
+            </a:pPr>
+            <a:r>
+              <a:t>Security</a:t>
+            </a:r>
+          </a:p>
+        </p:txBody>
+      </p:sp>
+      <p:cxnSp>
+        <p:nvCxnSpPr>
+          <p:cNvPr id="9" name="Connector 8"/>
+          <p:cNvCxnSpPr/>
+          <p:nvPr/>
+        </p:nvCxnSpPr>
+        <p:spPr>
+          <a:xfrm>
+            <a:off x="3017520" y="2103120.0"/>
+            <a:ext cx="137160" cy="0.0"/>
+          </a:xfrm>
+          <a:prstGeom prst="line">
+            <a:avLst/>
+          </a:prstGeom>
+          <a:ln>
+            <a:solidFill>
+              <a:srgbClr val="404040"/>
+            </a:solidFill>
+          </a:ln>
+        </p:spPr>
+        <p:style>
+          <a:lnRef idx="2">
+            <a:schemeClr val="accent1"/>
+          </a:lnRef>
+          <a:fillRef idx="0">
+            <a:schemeClr val="accent1"/>
+          </a:fillRef>
+          <a:effectRef idx="1">
+            <a:schemeClr val="accent1"/>
+          </a:effectRef>
+          <a:fontRef idx="minor">
+            <a:schemeClr val="tx1"/>
+          </a:fontRef>
+        </p:style>
+      </p:cxnSp>
+      <p:sp>
+        <p:nvSpPr>
+          <p:cNvPr id="10" name="Rounded Rectangle 9"/>
+          <p:cNvSpPr/>
+          <p:nvPr/>
+        </p:nvSpPr>
+        <p:spPr>
+          <a:xfrm>
+            <a:off x="3154680" y="1828800"/>
+            <a:ext cx="822960" cy="548640"/>
+          </a:xfrm>
+          <a:prstGeom prst="roundRect">
+            <a:avLst/>
+          </a:prstGeom>
+          <a:solidFill>
+            <a:srgbClr val="4CAF50"/>
+          </a:solidFill>
+          <a:ln>
+            <a:solidFill>
+              <a:srgbClr val="19376D"/>
+            </a:solidFill>
+          </a:ln>
+        </p:spPr>
+        <p:style>
+          <a:lnRef idx="1">
+            <a:schemeClr val="accent1"/>
+          </a:lnRef>
+          <a:fillRef idx="3">
+            <a:schemeClr val="accent1"/>
+          </a:fillRef>
+          <a:effectRef idx="2">
+            <a:schemeClr val="accent1"/>
+          </a:effectRef>
+          <a:fontRef idx="minor">
+            <a:schemeClr val="lt1"/>
+          </a:fontRef>
+        </p:style>
+        <p:txBody>
+          <a:bodyPr rtlCol="0" anchor="ctr"/>
+          <a:lstStyle/>
+          <a:p>
+            <a:pPr algn="ctr">
+              <a:defRPr sz="900" b="1">
+                <a:solidFill>
+                  <a:srgbClr val="FFFFFF"/>
+                </a:solidFill>
+              </a:defRPr>
+            </a:pPr>
+            <a:r>
+              <a:t>Customer</a:t>
+            </a:r>
+            <a:br/>
+            <a:r>
+              <a:t>Agent</a:t>
+            </a:r>
+          </a:p>
+        </p:txBody>
+      </p:sp>
+      <p:cxnSp>
+        <p:nvCxnSpPr>
+          <p:cNvPr id="11" name="Connector 10"/>
+          <p:cNvCxnSpPr/>
+          <p:nvPr/>
+        </p:nvCxnSpPr>
+        <p:spPr>
+          <a:xfrm>
+            <a:off x="3977640" y="2103120.0"/>
+            <a:ext cx="137160" cy="0.0"/>
+          </a:xfrm>
+          <a:prstGeom prst="line">
+            <a:avLst/>
+          </a:prstGeom>
+          <a:ln>
+            <a:solidFill>
+              <a:srgbClr val="404040"/>
+            </a:solidFill>
+          </a:ln>
+        </p:spPr>
+        <p:style>
+          <a:lnRef idx="2">
+            <a:schemeClr val="accent1"/>
+          </a:lnRef>
+          <a:fillRef idx="0">
+            <a:schemeClr val="accent1"/>
+          </a:fillRef>
+          <a:effectRef idx="1">
+            <a:schemeClr val="accent1"/>
+          </a:effectRef>
+          <a:fontRef idx="minor">
+            <a:schemeClr val="tx1"/>
+          </a:fontRef>
+        </p:style>
+      </p:cxnSp>
+      <p:sp>
+        <p:nvSpPr>
+          <p:cNvPr id="12" name="Rounded Rectangle 11"/>
+          <p:cNvSpPr/>
+          <p:nvPr/>
+        </p:nvSpPr>
+        <p:spPr>
+          <a:xfrm>
+            <a:off x="4114800" y="1828800"/>
+            <a:ext cx="822960" cy="548640"/>
+          </a:xfrm>
+          <a:prstGeom prst="roundRect">
+            <a:avLst/>
+          </a:prstGeom>
+          <a:solidFill>
+            <a:srgbClr val="4CAF50"/>
+          </a:solidFill>
+          <a:ln>
+            <a:solidFill>
+              <a:srgbClr val="19376D"/>
+            </a:solidFill>
+          </a:ln>
+        </p:spPr>
+        <p:style>
+          <a:lnRef idx="1">
+            <a:schemeClr val="accent1"/>
+          </a:lnRef>
+          <a:fillRef idx="3">
+            <a:schemeClr val="accent1"/>
+          </a:fillRef>
+          <a:effectRef idx="2">
+            <a:schemeClr val="accent1"/>
+          </a:effectRef>
+          <a:fontRef idx="minor">
+            <a:schemeClr val="lt1"/>
+          </a:fontRef>
+        </p:style>
+        <p:txBody>
+          <a:bodyPr rtlCol="0" anchor="ctr"/>
+          <a:lstStyle/>
+          <a:p>
+            <a:pPr algn="ctr">
+              <a:defRPr sz="900" b="1">
+                <a:solidFill>
+                  <a:srgbClr val="FFFFFF"/>
+                </a:solidFill>
+              </a:defRPr>
+            </a:pPr>
+            <a:r>
+              <a:t>Knowledge</a:t>
+            </a:r>
+            <a:br/>
+            <a:r>
+              <a:t>Agent</a:t>
+            </a:r>
+          </a:p>
+        </p:txBody>
+      </p:sp>
+      <p:cxnSp>
+        <p:nvCxnSpPr>
+          <p:cNvPr id="13" name="Connector 12"/>
+          <p:cNvCxnSpPr/>
+          <p:nvPr/>
+        </p:nvCxnSpPr>
+        <p:spPr>
+          <a:xfrm>
+            <a:off x="4937760" y="2103120.0"/>
+            <a:ext cx="137160" cy="0.0"/>
+          </a:xfrm>
+          <a:prstGeom prst="line">
+            <a:avLst/>
+          </a:prstGeom>
+          <a:ln>
+            <a:solidFill>
+              <a:srgbClr val="404040"/>
+            </a:solidFill>
+          </a:ln>
+        </p:spPr>
+        <p:style>
+          <a:lnRef idx="2">
+            <a:schemeClr val="accent1"/>
+          </a:lnRef>
+          <a:fillRef idx="0">
+            <a:schemeClr val="accent1"/>
+          </a:fillRef>
+          <a:effectRef idx="1">
+            <a:schemeClr val="accent1"/>
+          </a:effectRef>
+          <a:fontRef idx="minor">
+            <a:schemeClr val="tx1"/>
+          </a:fontRef>
+        </p:style>
+      </p:cxnSp>
+      <p:sp>
+        <p:nvSpPr>
+          <p:cNvPr id="14" name="Rounded Rectangle 13"/>
+          <p:cNvSpPr/>
+          <p:nvPr/>
+        </p:nvSpPr>
+        <p:spPr>
+          <a:xfrm>
+            <a:off x="5074920" y="1828800"/>
+            <a:ext cx="822960" cy="548640"/>
+          </a:xfrm>
+          <a:prstGeom prst="roundRect">
+            <a:avLst/>
+          </a:prstGeom>
+          <a:solidFill>
+            <a:srgbClr val="4CAF50"/>
+          </a:solidFill>
+          <a:ln>
+            <a:solidFill>
+              <a:srgbClr val="19376D"/>
+            </a:solidFill>
+          </a:ln>
+        </p:spPr>
+        <p:style>
+          <a:lnRef idx="1">
+            <a:schemeClr val="accent1"/>
+          </a:lnRef>
+          <a:fillRef idx="3">
+            <a:schemeClr val="accent1"/>
+          </a:fillRef>
+          <a:effectRef idx="2">
+            <a:schemeClr val="accent1"/>
+          </a:effectRef>
+          <a:fontRef idx="minor">
+            <a:schemeClr val="lt1"/>
+          </a:fontRef>
+        </p:style>
+        <p:txBody>
+          <a:bodyPr rtlCol="0" anchor="ctr"/>
+          <a:lstStyle/>
+          <a:p>
+            <a:pPr algn="ctr">
+              <a:defRPr sz="900" b="1">
+                <a:solidFill>
+                  <a:srgbClr val="FFFFFF"/>
+                </a:solidFill>
+              </a:defRPr>
+            </a:pPr>
+            <a:r>
+              <a:t>Compliance</a:t>
+            </a:r>
+            <a:br/>
+            <a:r>
+              <a:t>&amp; Risk</a:t>
+            </a:r>
+          </a:p>
+        </p:txBody>
+      </p:sp>
+      <p:cxnSp>
+        <p:nvCxnSpPr>
+          <p:cNvPr id="15" name="Connector 14"/>
+          <p:cNvCxnSpPr/>
+          <p:nvPr/>
+        </p:nvCxnSpPr>
+        <p:spPr>
+          <a:xfrm>
+            <a:off x="5897880" y="2103120.0"/>
+            <a:ext cx="137160" cy="0.0"/>
+          </a:xfrm>
+          <a:prstGeom prst="line">
+            <a:avLst/>
+          </a:prstGeom>
+          <a:ln>
+            <a:solidFill>
+              <a:srgbClr val="404040"/>
+            </a:solidFill>
+          </a:ln>
+        </p:spPr>
+        <p:style>
+          <a:lnRef idx="2">
+            <a:schemeClr val="accent1"/>
+          </a:lnRef>
+          <a:fillRef idx="0">
+            <a:schemeClr val="accent1"/>
+          </a:fillRef>
+          <a:effectRef idx="1">
+            <a:schemeClr val="accent1"/>
+          </a:effectRef>
+          <a:fontRef idx="minor">
+            <a:schemeClr val="tx1"/>
+          </a:fontRef>
+        </p:style>
+      </p:cxnSp>
+      <p:sp>
+        <p:nvSpPr>
+          <p:cNvPr id="16" name="Rounded Rectangle 15"/>
+          <p:cNvSpPr/>
+          <p:nvPr/>
+        </p:nvSpPr>
+        <p:spPr>
+          <a:xfrm>
+            <a:off x="6035040" y="1828800"/>
+            <a:ext cx="822960" cy="548640"/>
+          </a:xfrm>
+          <a:prstGeom prst="roundRect">
+            <a:avLst/>
+          </a:prstGeom>
+          <a:solidFill>
+            <a:srgbClr val="4CAF50"/>
+          </a:solidFill>
+          <a:ln>
+            <a:solidFill>
+              <a:srgbClr val="19376D"/>
+            </a:solidFill>
+          </a:ln>
+        </p:spPr>
+        <p:style>
+          <a:lnRef idx="1">
+            <a:schemeClr val="accent1"/>
+          </a:lnRef>
+          <a:fillRef idx="3">
+            <a:schemeClr val="accent1"/>
+          </a:fillRef>
+          <a:effectRef idx="2">
+            <a:schemeClr val="accent1"/>
+          </a:effectRef>
+          <a:fontRef idx="minor">
+            <a:schemeClr val="lt1"/>
+          </a:fontRef>
+        </p:style>
+        <p:txBody>
+          <a:bodyPr rtlCol="0" anchor="ctr"/>
+          <a:lstStyle/>
+          <a:p>
+            <a:pPr algn="ctr">
+              <a:defRPr sz="900" b="1">
+                <a:solidFill>
+                  <a:srgbClr val="FFFFFF"/>
+                </a:solidFill>
+              </a:defRPr>
+            </a:pPr>
+            <a:r>
+              <a:t>Decision</a:t>
+            </a:r>
+            <a:br/>
+            <a:r>
+              <a:t>Agent</a:t>
+            </a:r>
+          </a:p>
+        </p:txBody>
+      </p:sp>
+      <p:cxnSp>
+        <p:nvCxnSpPr>
+          <p:cNvPr id="17" name="Connector 16"/>
+          <p:cNvCxnSpPr/>
+          <p:nvPr/>
+        </p:nvCxnSpPr>
+        <p:spPr>
+          <a:xfrm>
+            <a:off x="6858000" y="2103120.0"/>
+            <a:ext cx="137160" cy="0.0"/>
+          </a:xfrm>
+          <a:prstGeom prst="line">
+            <a:avLst/>
+          </a:prstGeom>
+          <a:ln>
+            <a:solidFill>
+              <a:srgbClr val="404040"/>
+            </a:solidFill>
+          </a:ln>
+        </p:spPr>
+        <p:style>
+          <a:lnRef idx="2">
+            <a:schemeClr val="accent1"/>
+          </a:lnRef>
+          <a:fillRef idx="0">
+            <a:schemeClr val="accent1"/>
+          </a:fillRef>
+          <a:effectRef idx="1">
+            <a:schemeClr val="accent1"/>
+          </a:effectRef>
+          <a:fontRef idx="minor">
+            <a:schemeClr val="tx1"/>
+          </a:fontRef>
+        </p:style>
+      </p:cxnSp>
+      <p:sp>
+        <p:nvSpPr>
+          <p:cNvPr id="18" name="Rounded Rectangle 17"/>
+          <p:cNvSpPr/>
+          <p:nvPr/>
+        </p:nvSpPr>
+        <p:spPr>
+          <a:xfrm>
+            <a:off x="6995160" y="1828800"/>
+            <a:ext cx="822960" cy="548640"/>
+          </a:xfrm>
+          <a:prstGeom prst="roundRect">
+            <a:avLst/>
+          </a:prstGeom>
+          <a:solidFill>
+            <a:srgbClr val="4CAF50"/>
+          </a:solidFill>
+          <a:ln>
+            <a:solidFill>
+              <a:srgbClr val="19376D"/>
+            </a:solidFill>
+          </a:ln>
+        </p:spPr>
+        <p:style>
+          <a:lnRef idx="1">
+            <a:schemeClr val="accent1"/>
+          </a:lnRef>
+          <a:fillRef idx="3">
+            <a:schemeClr val="accent1"/>
+          </a:fillRef>
+          <a:effectRef idx="2">
+            <a:schemeClr val="accent1"/>
+          </a:effectRef>
+          <a:fontRef idx="minor">
+            <a:schemeClr val="lt1"/>
+          </a:fontRef>
+        </p:style>
+        <p:txBody>
+          <a:bodyPr rtlCol="0" anchor="ctr"/>
+          <a:lstStyle/>
+          <a:p>
+            <a:pPr algn="ctr">
+              <a:defRPr sz="900" b="1">
+                <a:solidFill>
+                  <a:srgbClr val="FFFFFF"/>
+                </a:solidFill>
+              </a:defRPr>
+            </a:pPr>
+            <a:r>
+              <a:t>Audit</a:t>
+            </a:r>
+            <a:br/>
+            <a:r>
+              <a:t>Agent</a:t>
+            </a:r>
+          </a:p>
+        </p:txBody>
+      </p:sp>
+      <p:cxnSp>
+        <p:nvCxnSpPr>
+          <p:cNvPr id="19" name="Connector 18"/>
+          <p:cNvCxnSpPr/>
+          <p:nvPr/>
+        </p:nvCxnSpPr>
+        <p:spPr>
+          <a:xfrm>
+            <a:off x="7818120" y="2103120.0"/>
+            <a:ext cx="137160" cy="0.0"/>
+          </a:xfrm>
+          <a:prstGeom prst="line">
+            <a:avLst/>
+          </a:prstGeom>
+          <a:ln>
+            <a:solidFill>
+              <a:srgbClr val="404040"/>
+            </a:solidFill>
+          </a:ln>
+        </p:spPr>
+        <p:style>
+          <a:lnRef idx="2">
+            <a:schemeClr val="accent1"/>
+          </a:lnRef>
+          <a:fillRef idx="0">
+            <a:schemeClr val="accent1"/>
+          </a:fillRef>
+          <a:effectRef idx="1">
+            <a:schemeClr val="accent1"/>
+          </a:effectRef>
+          <a:fontRef idx="minor">
+            <a:schemeClr val="tx1"/>
+          </a:fontRef>
+        </p:style>
+      </p:cxnSp>
+      <p:sp>
+        <p:nvSpPr>
+          <p:cNvPr id="20" name="Rounded Rectangle 19"/>
+          <p:cNvSpPr/>
+          <p:nvPr/>
+        </p:nvSpPr>
+        <p:spPr>
+          <a:xfrm>
+            <a:off x="7955280" y="1828800"/>
+            <a:ext cx="822960" cy="548640"/>
+          </a:xfrm>
+          <a:prstGeom prst="roundRect">
+            <a:avLst/>
+          </a:prstGeom>
+          <a:solidFill>
+            <a:srgbClr val="FF7F27"/>
+          </a:solidFill>
+          <a:ln>
+            <a:solidFill>
+              <a:srgbClr val="19376D"/>
+            </a:solidFill>
+          </a:ln>
+        </p:spPr>
+        <p:style>
+          <a:lnRef idx="1">
+            <a:schemeClr val="accent1"/>
+          </a:lnRef>
+          <a:fillRef idx="3">
+            <a:schemeClr val="accent1"/>
+          </a:fillRef>
+          <a:effectRef idx="2">
+            <a:schemeClr val="accent1"/>
+          </a:effectRef>
+          <a:fontRef idx="minor">
+            <a:schemeClr val="lt1"/>
+          </a:fontRef>
+        </p:style>
+        <p:txBody>
+          <a:bodyPr rtlCol="0" anchor="ctr"/>
+          <a:lstStyle/>
+          <a:p>
+            <a:pPr algn="ctr">
+              <a:defRPr sz="900" b="1">
+                <a:solidFill>
+                  <a:srgbClr val="FFFFFF"/>
+                </a:solidFill>
+              </a:defRPr>
+            </a:pPr>
+            <a:r>
+              <a:t>OUTPUT</a:t>
+            </a:r>
+          </a:p>
+        </p:txBody>
+      </p:sp>
+      <p:sp>
+        <p:nvSpPr>
+          <p:cNvPr id="21" name="TextBox 20"/>
+          <p:cNvSpPr txBox="1"/>
+          <p:nvPr/>
+        </p:nvSpPr>
+        <p:spPr>
+          <a:xfrm>
+            <a:off x="457200" y="2926080"/>
+            <a:ext cx="8229600" cy="3474720"/>
+          </a:xfrm>
+          <a:prstGeom prst="rect">
+            <a:avLst/>
+          </a:prstGeom>
+          <a:noFill/>
+        </p:spPr>
+        <p:txBody>
+          <a:bodyPr wrap="square">
+            <a:spAutoFit/>
+          </a:bodyPr>
+          <a:lstStyle/>
+          <a:p>
+            <a:pPr>
+              <a:spcBef>
+                <a:spcPts val="600"/>
+              </a:spcBef>
+              <a:spcAft>
+                <a:spcPts val="600"/>
+              </a:spcAft>
+              <a:defRPr sz="1200">
+                <a:solidFill>
+                  <a:srgbClr val="404040"/>
+                </a:solidFill>
+              </a:defRPr>
+            </a:pPr>
+            <a:r>
+              <a:t>Assessment Pipeline Execution:</a:t>
+            </a:r>
+            <a:br/>
+            <a:r>
+              <a:t>    </a:t>
+            </a:r>
+            <a:br/>
+            <a:r>
+              <a:t>    ✓ InputValidationHook    — Sanitizes and validates claim data</a:t>
+            </a:r>
+            <a:br/>
+            <a:r>
+              <a:t>    ✓ SecurityHook           — Authenticates and authorizes access</a:t>
+            </a:r>
+            <a:br/>
+            <a:r>
+              <a:t>    ✓ CustomerAgent          — Validates identity and extracts claim data</a:t>
+            </a:r>
+            <a:br/>
+            <a:r>
+              <a:t>    ✓ KnowledgeAgent (MCP)   — Retrieves regulatory knowledge and policies</a:t>
+            </a:r>
+            <a:br/>
+            <a:r>
+              <a:t>    ✓ ComplianceAgent        — Validates IRDAI, SOX, AML compliance</a:t>
+            </a:r>
+            <a:br/>
+            <a:r>
+              <a:t>    ✓ RiskAgent              — Performs fraud detection and risk scoring</a:t>
+            </a:r>
+            <a:br/>
+            <a:r>
+              <a:t>    ✓ DecisionAgent          — Synthesizes all outputs and makes recommendation</a:t>
+            </a:r>
+            <a:br/>
+            <a:r>
+              <a:t>    ✓ AuditAgent             — Creates immutable audit trail</a:t>
+            </a:r>
+            <a:br/>
+            <a:r>
+              <a:t>    ✓ OutputValidationHook   — Validates final decision before delivery</a:t>
+            </a:r>
+          </a:p>
+        </p:txBody>
+      </p:sp>
+    </p:spTree>
+  </p:cSld>
+  <p:clrMapOvr>
+    <a:masterClrMapping/>
+  </p:clrMapOvr>
+</p:sld>
+</file>
+
+<file path=ppt/slides/slide25.xml><?xml version="1.0" encoding="utf-8"?>
+<p:sld xmlns:a="http://schemas.openxmlformats.org/drawingml/2006/main" xmlns:p="http://schemas.openxmlformats.org/presentationml/2006/main" xmlns:r="http://schemas.openxmlformats.org/officeDocument/2006/relationships">
+  <p:cSld>
+    <p:bg>
+      <p:bgPr>
+        <a:solidFill>
+          <a:srgbClr val="FFFFFF"/>
+        </a:solidFill>
+        <a:effectLst/>
+      </p:bgPr>
+    </p:bg>
+    <p:spTree>
+      <p:nvGrpSpPr>
+        <p:cNvPr id="1" name=""/>
+        <p:cNvGrpSpPr/>
+        <p:nvPr/>
+      </p:nvGrpSpPr>
+      <p:grpSpPr/>
+      <p:sp>
+        <p:nvSpPr>
+          <p:cNvPr id="2" name="Rectangle 1"/>
+          <p:cNvSpPr/>
+          <p:nvPr/>
+        </p:nvSpPr>
+        <p:spPr>
+          <a:xfrm>
+            <a:off x="0" y="0"/>
+            <a:ext cx="9144000" cy="731520"/>
+          </a:xfrm>
+          <a:prstGeom prst="rect">
+            <a:avLst/>
+          </a:prstGeom>
+          <a:solidFill>
+            <a:srgbClr val="19376D"/>
+          </a:solidFill>
+          <a:ln>
+            <a:solidFill>
+              <a:srgbClr val="19376D"/>
+            </a:solidFill>
+          </a:ln>
+        </p:spPr>
+        <p:style>
+          <a:lnRef idx="1">
+            <a:schemeClr val="accent1"/>
+          </a:lnRef>
+          <a:fillRef idx="3">
+            <a:schemeClr val="accent1"/>
+          </a:fillRef>
+          <a:effectRef idx="2">
+            <a:schemeClr val="accent1"/>
+          </a:effectRef>
+          <a:fontRef idx="minor">
+            <a:schemeClr val="lt1"/>
+          </a:fontRef>
+        </p:style>
+        <p:txBody>
+          <a:bodyPr rtlCol="0" anchor="ctr"/>
+          <a:lstStyle/>
+          <a:p>
+            <a:pPr algn="ctr"/>
+          </a:p>
+        </p:txBody>
+      </p:sp>
+      <p:sp>
+        <p:nvSpPr>
+          <p:cNvPr id="3" name="TextBox 2"/>
+          <p:cNvSpPr txBox="1"/>
+          <p:nvPr/>
+        </p:nvSpPr>
+        <p:spPr>
+          <a:xfrm>
+            <a:off x="457200" y="137160"/>
+            <a:ext cx="8229600" cy="548640"/>
+          </a:xfrm>
+          <a:prstGeom prst="rect">
+            <a:avLst/>
+          </a:prstGeom>
+          <a:noFill/>
+        </p:spPr>
+        <p:txBody>
+          <a:bodyPr wrap="none">
+            <a:spAutoFit/>
+          </a:bodyPr>
+          <a:lstStyle/>
+          <a:p>
+            <a:pPr>
+              <a:defRPr sz="3200" b="1">
+                <a:solidFill>
+                  <a:srgbClr val="FFFFFF"/>
+                </a:solidFill>
+              </a:defRPr>
+            </a:pPr>
+            <a:r>
+              <a:t>Slide 25: Real-Time Dashboard UI</a:t>
+            </a:r>
+          </a:p>
+        </p:txBody>
+      </p:sp>
+      <p:sp>
+        <p:nvSpPr>
+          <p:cNvPr id="4" name="TextBox 3"/>
+          <p:cNvSpPr txBox="1"/>
+          <p:nvPr/>
+        </p:nvSpPr>
+        <p:spPr>
+          <a:xfrm>
+            <a:off x="457200" y="1005840"/>
+            <a:ext cx="8229600" cy="5486400"/>
+          </a:xfrm>
+          <a:prstGeom prst="rect">
+            <a:avLst/>
+          </a:prstGeom>
+          <a:noFill/>
+        </p:spPr>
+        <p:txBody>
+          <a:bodyPr wrap="square">
+            <a:spAutoFit/>
+          </a:bodyPr>
+          <a:lstStyle/>
+          <a:p>
+            <a:pPr>
+              <a:spcBef>
+                <a:spcPts val="200"/>
+              </a:spcBef>
+              <a:spcAft>
+                <a:spcPts val="200"/>
+              </a:spcAft>
+              <a:defRPr sz="1100">
+                <a:solidFill>
+                  <a:srgbClr val="404040"/>
+                </a:solidFill>
+                <a:latin typeface="Courier New"/>
+              </a:defRPr>
+            </a:pPr>
+            <a:r>
+              <a:t>🛡️ DASHBOARD FEATURES &amp; REAL-TIME MONITORING</a:t>
+            </a:r>
+            <a:br/>
+            <a:r>
+              <a:t>    </a:t>
+            </a:r>
+            <a:br/>
+            <a:r>
+              <a:t>    ┌─────────────────────────────────────────────────────────────┐</a:t>
+            </a:r>
+            <a:br/>
+            <a:r>
+              <a:t>    │ Total Claims: 2         │ Approved: 0        │ Rejected: 0   │</a:t>
+            </a:r>
+            <a:br/>
+            <a:r>
+              <a:t>    │ Pending Review: 0       │ Avg Fraud Score: 0.0  │ Avg Claim: $6K │</a:t>
+            </a:r>
+            <a:br/>
+            <a:r>
+              <a:t>    └─────────────────────────────────────────────────────────────┘</a:t>
+            </a:r>
+            <a:br/>
+            <a:r>
+              <a:t>    </a:t>
+            </a:r>
+            <a:br/>
+            <a:r>
+              <a:t>    AGENT STATUS (All 6 Operational):</a:t>
+            </a:r>
+            <a:br/>
+            <a:r>
+              <a:t>    ┌──────────────────────────────────────────────────────────────────┐</a:t>
+            </a:r>
+            <a:br/>
+            <a:r>
+              <a:t>    │ ✓ CustomerAgent      — Identity validation &amp; claim extraction    │</a:t>
+            </a:r>
+            <a:br/>
+            <a:r>
+              <a:t>    │ ✓ KnowledgeAgent     — Regulatory knowledge (MCP-enhanced)      │</a:t>
+            </a:r>
+            <a:br/>
+            <a:r>
+              <a:t>    │ ✓ ComplianceAgent    — IRDAI / SOX / AML validation            │</a:t>
+            </a:r>
+            <a:br/>
+            <a:r>
+              <a:t>    │ ✓ RiskAgent          — Fraud detection &amp; risk scoring           │</a:t>
+            </a:r>
+            <a:br/>
+            <a:r>
+              <a:t>    │ ✓ DecisionAgent      — Final assessment synthesis               │</a:t>
+            </a:r>
+            <a:br/>
+            <a:r>
+              <a:t>    │ ✓ AuditAgent         — Immutable audit trail generation         │</a:t>
+            </a:r>
+            <a:br/>
+            <a:r>
+              <a:t>    └──────────────────────────────────────────────────────────────────┘</a:t>
+            </a:r>
+            <a:br/>
+            <a:r>
+              <a:t>    </a:t>
+            </a:r>
+            <a:br/>
+            <a:r>
+              <a:t>    SYSTEM COMPONENTS STATUS:</a:t>
+            </a:r>
+            <a:br/>
+            <a:r>
+              <a:t>    ┓ MCP — RegulatoryKnowledgeBase   ✓ Connected</a:t>
+            </a:r>
+            <a:br/>
+            <a:r>
+              <a:t>    ┓ Database — SQLite + SQLAlchemy  ✓ Healthy</a:t>
+            </a:r>
+            <a:br/>
+            <a:r>
+              <a:t>    ┓ All Hooks (5 total)             ✓ Active</a:t>
+            </a:r>
+            <a:br/>
+            <a:r>
+              <a:t>    ┓ DocumentProcessingTool          ✓ Active</a:t>
+            </a:r>
+          </a:p>
+        </p:txBody>
+      </p:sp>
+    </p:spTree>
+  </p:cSld>
+  <p:clrMapOvr>
+    <a:masterClrMapping/>
+  </p:clrMapOvr>
+</p:sld>
+</file>
+
+<file path=ppt/slides/slide26.xml><?xml version="1.0" encoding="utf-8"?>
+<p:sld xmlns:a="http://schemas.openxmlformats.org/drawingml/2006/main" xmlns:p="http://schemas.openxmlformats.org/presentationml/2006/main" xmlns:r="http://schemas.openxmlformats.org/officeDocument/2006/relationships">
+  <p:cSld>
+    <p:bg>
+      <p:bgPr>
+        <a:solidFill>
+          <a:srgbClr val="FFFFFF"/>
+        </a:solidFill>
+        <a:effectLst/>
+      </p:bgPr>
+    </p:bg>
+    <p:spTree>
+      <p:nvGrpSpPr>
+        <p:cNvPr id="1" name=""/>
+        <p:cNvGrpSpPr/>
+        <p:nvPr/>
+      </p:nvGrpSpPr>
+      <p:grpSpPr/>
+      <p:sp>
+        <p:nvSpPr>
+          <p:cNvPr id="2" name="Rectangle 1"/>
+          <p:cNvSpPr/>
+          <p:nvPr/>
+        </p:nvSpPr>
+        <p:spPr>
+          <a:xfrm>
+            <a:off x="0" y="0"/>
+            <a:ext cx="9144000" cy="731520"/>
+          </a:xfrm>
+          <a:prstGeom prst="rect">
+            <a:avLst/>
+          </a:prstGeom>
+          <a:solidFill>
+            <a:srgbClr val="19376D"/>
+          </a:solidFill>
+          <a:ln>
+            <a:solidFill>
+              <a:srgbClr val="19376D"/>
+            </a:solidFill>
+          </a:ln>
+        </p:spPr>
+        <p:style>
+          <a:lnRef idx="1">
+            <a:schemeClr val="accent1"/>
+          </a:lnRef>
+          <a:fillRef idx="3">
+            <a:schemeClr val="accent1"/>
+          </a:fillRef>
+          <a:effectRef idx="2">
+            <a:schemeClr val="accent1"/>
+          </a:effectRef>
+          <a:fontRef idx="minor">
+            <a:schemeClr val="lt1"/>
+          </a:fontRef>
+        </p:style>
+        <p:txBody>
+          <a:bodyPr rtlCol="0" anchor="ctr"/>
+          <a:lstStyle/>
+          <a:p>
+            <a:pPr algn="ctr"/>
+          </a:p>
+        </p:txBody>
+      </p:sp>
+      <p:sp>
+        <p:nvSpPr>
+          <p:cNvPr id="3" name="TextBox 2"/>
+          <p:cNvSpPr txBox="1"/>
+          <p:nvPr/>
+        </p:nvSpPr>
+        <p:spPr>
+          <a:xfrm>
+            <a:off x="457200" y="137160"/>
+            <a:ext cx="8229600" cy="548640"/>
+          </a:xfrm>
+          <a:prstGeom prst="rect">
+            <a:avLst/>
+          </a:prstGeom>
+          <a:noFill/>
+        </p:spPr>
+        <p:txBody>
+          <a:bodyPr wrap="none">
+            <a:spAutoFit/>
+          </a:bodyPr>
+          <a:lstStyle/>
+          <a:p>
+            <a:pPr>
+              <a:defRPr sz="3200" b="1">
+                <a:solidFill>
+                  <a:srgbClr val="FFFFFF"/>
+                </a:solidFill>
+              </a:defRPr>
+            </a:pPr>
+            <a:r>
+              <a:t>Slide 26: Multi-Agent Interaction Pattern</a:t>
+            </a:r>
+          </a:p>
+        </p:txBody>
+      </p:sp>
+      <p:sp>
+        <p:nvSpPr>
+          <p:cNvPr id="4" name="TextBox 3"/>
+          <p:cNvSpPr txBox="1"/>
+          <p:nvPr/>
+        </p:nvSpPr>
+        <p:spPr>
+          <a:xfrm>
+            <a:off x="457200" y="1005840"/>
+            <a:ext cx="8229600" cy="5486400"/>
+          </a:xfrm>
+          <a:prstGeom prst="rect">
+            <a:avLst/>
+          </a:prstGeom>
+          <a:noFill/>
+        </p:spPr>
+        <p:txBody>
+          <a:bodyPr wrap="square">
+            <a:spAutoFit/>
+          </a:bodyPr>
+          <a:lstStyle/>
+          <a:p>
+            <a:pPr>
+              <a:spcBef>
+                <a:spcPts val="200"/>
+              </a:spcBef>
+              <a:spcAft>
+                <a:spcPts val="200"/>
+              </a:spcAft>
+              <a:defRPr sz="1100">
+                <a:solidFill>
+                  <a:srgbClr val="404040"/>
+                </a:solidFill>
+                <a:latin typeface="Courier New"/>
+              </a:defRPr>
+            </a:pPr>
+            <a:r>
+              <a:t>MULTI-AGENT INTERACTION PATTERN</a:t>
+            </a:r>
+            <a:br/>
+            <a:r>
+              <a:t>    </a:t>
+            </a:r>
+            <a:br/>
+            <a:r>
+              <a:t>    ① INPUT LAYER</a:t>
+            </a:r>
+            <a:br/>
+            <a:r>
+              <a:t>       ↓</a:t>
+            </a:r>
+            <a:br/>
+            <a:r>
+              <a:t>    ② CUSTOMER AGENT (Validates customer &amp; extracts claim data)</a:t>
+            </a:r>
+            <a:br/>
+            <a:r>
+              <a:t>       ↓</a:t>
+            </a:r>
+            <a:br/>
+            <a:r>
+              <a:t>    ③ KNOWLEDGE AGENT (Retrieves regulatory knowledge via MCP)</a:t>
+            </a:r>
+            <a:br/>
+            <a:r>
+              <a:t>       ↓</a:t>
+            </a:r>
+            <a:br/>
+            <a:r>
+              <a:t>    ④ PARALLEL EXECUTION:</a:t>
+            </a:r>
+            <a:br/>
+            <a:r>
+              <a:t>       ├─ COMPLIANCE AGENT (IRDAI/SOX/AML validation)</a:t>
+            </a:r>
+            <a:br/>
+            <a:r>
+              <a:t>       └─ RISK AGENT (Fraud detection &amp; anomaly scoring)</a:t>
+            </a:r>
+            <a:br/>
+            <a:r>
+              <a:t>       ↓</a:t>
+            </a:r>
+            <a:br/>
+            <a:r>
+              <a:t>    ⑤ DECISION AGENT (Synthesizes results → Final recommendation)</a:t>
+            </a:r>
+            <a:br/>
+            <a:r>
+              <a:t>       ├─ Approval with confidence score</a:t>
+            </a:r>
+            <a:br/>
+            <a:r>
+              <a:t>       ├─ Rejection with reasoning</a:t>
+            </a:r>
+            <a:br/>
+            <a:r>
+              <a:t>       └─ Pending Review with required actions</a:t>
+            </a:r>
+            <a:br/>
+            <a:r>
+              <a:t>       ↓</a:t>
+            </a:r>
+            <a:br/>
+            <a:r>
+              <a:t>    ⑥ AUDIT AGENT (Creates immutable record)</a:t>
+            </a:r>
+            <a:br/>
+            <a:r>
+              <a:t>       └─ Hash-chained audit log</a:t>
+            </a:r>
+            <a:br/>
+            <a:r>
+              <a:t>       └─ Decision reasoning</a:t>
+            </a:r>
+            <a:br/>
+            <a:r>
+              <a:t>       └─ Compliance validation results</a:t>
+            </a:r>
+            <a:br/>
+            <a:r>
+              <a:t>       ↓</a:t>
+            </a:r>
+            <a:br/>
+            <a:r>
+              <a:t>    ⑦ OUTPUT LAYER</a:t>
+            </a:r>
+            <a:br/>
+            <a:r>
+              <a:t>       ├─ Assessment result (Decision + Confidence)</a:t>
+            </a:r>
+            <a:br/>
+            <a:r>
+              <a:t>       ├─ Audit trail (Complete history)</a:t>
+            </a:r>
+            <a:br/>
+            <a:r>
+              <a:t>       └─ Explainable reasoning (Why decision made)</a:t>
+            </a:r>
+            <a:br/>
+            <a:r>
+              <a:t>    </a:t>
+            </a:r>
+            <a:br/>
+            <a:r>
+              <a:t>    Each agent communicates via AgentResult dataclass:</a:t>
+            </a:r>
+            <a:br/>
+            <a:r>
+              <a:t>    • agent_name, success, data, reasoning, confidence, duration_ms, error</a:t>
+            </a:r>
+          </a:p>
+        </p:txBody>
+      </p:sp>
+    </p:spTree>
+  </p:cSld>
+  <p:clrMapOvr>
+    <a:masterClrMapping/>
+  </p:clrMapOvr>
+</p:sld>
+</file>
+
+<file path=ppt/slides/slide27.xml><?xml version="1.0" encoding="utf-8"?>
+<p:sld xmlns:a="http://schemas.openxmlformats.org/drawingml/2006/main" xmlns:p="http://schemas.openxmlformats.org/presentationml/2006/main" xmlns:r="http://schemas.openxmlformats.org/officeDocument/2006/relationships">
+  <p:cSld>
+    <p:bg>
+      <p:bgPr>
+        <a:solidFill>
+          <a:srgbClr val="FFFFFF"/>
+        </a:solidFill>
+        <a:effectLst/>
+      </p:bgPr>
+    </p:bg>
+    <p:spTree>
+      <p:nvGrpSpPr>
+        <p:cNvPr id="1" name=""/>
+        <p:cNvGrpSpPr/>
+        <p:nvPr/>
+      </p:nvGrpSpPr>
+      <p:grpSpPr/>
+      <p:sp>
+        <p:nvSpPr>
+          <p:cNvPr id="2" name="Rectangle 1"/>
+          <p:cNvSpPr/>
+          <p:nvPr/>
+        </p:nvSpPr>
+        <p:spPr>
+          <a:xfrm>
+            <a:off x="0" y="0"/>
+            <a:ext cx="9144000" cy="731520"/>
+          </a:xfrm>
+          <a:prstGeom prst="rect">
+            <a:avLst/>
+          </a:prstGeom>
+          <a:solidFill>
+            <a:srgbClr val="19376D"/>
+          </a:solidFill>
+          <a:ln>
+            <a:solidFill>
+              <a:srgbClr val="19376D"/>
+            </a:solidFill>
+          </a:ln>
+        </p:spPr>
+        <p:style>
+          <a:lnRef idx="1">
+            <a:schemeClr val="accent1"/>
+          </a:lnRef>
+          <a:fillRef idx="3">
+            <a:schemeClr val="accent1"/>
+          </a:fillRef>
+          <a:effectRef idx="2">
+            <a:schemeClr val="accent1"/>
+          </a:effectRef>
+          <a:fontRef idx="minor">
+            <a:schemeClr val="lt1"/>
+          </a:fontRef>
+        </p:style>
+        <p:txBody>
+          <a:bodyPr rtlCol="0" anchor="ctr"/>
+          <a:lstStyle/>
+          <a:p>
+            <a:pPr algn="ctr"/>
+          </a:p>
+        </p:txBody>
+      </p:sp>
+      <p:sp>
+        <p:nvSpPr>
+          <p:cNvPr id="3" name="TextBox 2"/>
+          <p:cNvSpPr txBox="1"/>
+          <p:nvPr/>
+        </p:nvSpPr>
+        <p:spPr>
+          <a:xfrm>
+            <a:off x="457200" y="137160"/>
+            <a:ext cx="8229600" cy="548640"/>
+          </a:xfrm>
+          <a:prstGeom prst="rect">
+            <a:avLst/>
+          </a:prstGeom>
+          <a:noFill/>
+        </p:spPr>
+        <p:txBody>
+          <a:bodyPr wrap="square">
+            <a:spAutoFit/>
+          </a:bodyPr>
+          <a:lstStyle/>
+          <a:p>
+            <a:pPr>
+              <a:defRPr sz="3200" b="1">
+                <a:solidFill>
+                  <a:srgbClr val="FFFFFF"/>
+                </a:solidFill>
+              </a:defRPr>
+            </a:pPr>
+            <a:r>
+              <a:t>Slide 27: Assessment Results Sample</a:t>
+            </a:r>
+          </a:p>
+        </p:txBody>
+      </p:sp>
+      <p:sp>
+        <p:nvSpPr>
+          <p:cNvPr id="4" name="TextBox 3"/>
+          <p:cNvSpPr txBox="1"/>
+          <p:nvPr/>
+        </p:nvSpPr>
+        <p:spPr>
+          <a:xfrm>
+            <a:off x="640080" y="1097280"/>
+            <a:ext cx="7863840" cy="5303520"/>
+          </a:xfrm>
+          <a:prstGeom prst="rect">
+            <a:avLst/>
+          </a:prstGeom>
+          <a:noFill/>
+        </p:spPr>
+        <p:txBody>
+          <a:bodyPr wrap="square">
+            <a:spAutoFit/>
+          </a:bodyPr>
+          <a:lstStyle/>
+          <a:p/>
+          <a:p>
+            <a:pPr lvl="1">
+              <a:spcBef>
+                <a:spcPts val="400"/>
+              </a:spcBef>
+              <a:spcAft>
+                <a:spcPts val="400"/>
+              </a:spcAft>
+              <a:defRPr sz="1400">
+                <a:solidFill>
+                  <a:srgbClr val="404040"/>
+                </a:solidFill>
+              </a:defRPr>
+            </a:pPr>
+            <a:r>
+              <a:t>Example Assessment Output (from Dashboard):</a:t>
+            </a:r>
+          </a:p>
+          <a:p>
+            <a:pPr lvl="1">
+              <a:spcBef>
+                <a:spcPts val="400"/>
+              </a:spcBef>
+              <a:spcAft>
+                <a:spcPts val="400"/>
+              </a:spcAft>
+              <a:defRPr sz="1400">
+                <a:solidFill>
+                  <a:srgbClr val="404040"/>
+                </a:solidFill>
+              </a:defRPr>
+            </a:pPr>
+            <a:r>
+              <a:t>┌─────────────────────────────────────────────────────────┐</a:t>
+            </a:r>
+          </a:p>
+          <a:p>
+            <a:pPr lvl="1">
+              <a:spcBef>
+                <a:spcPts val="400"/>
+              </a:spcBef>
+              <a:spcAft>
+                <a:spcPts val="400"/>
+              </a:spcAft>
+              <a:defRPr sz="1400">
+                <a:solidFill>
+                  <a:srgbClr val="404040"/>
+                </a:solidFill>
+              </a:defRPr>
+            </a:pPr>
+            <a:r>
+              <a:t>│ CLAIM: CLM-20260614-9FB40756                            │</a:t>
+            </a:r>
+          </a:p>
+          <a:p>
+            <a:pPr lvl="1">
+              <a:spcBef>
+                <a:spcPts val="400"/>
+              </a:spcBef>
+              <a:spcAft>
+                <a:spcPts val="400"/>
+              </a:spcAft>
+              <a:defRPr sz="1400">
+                <a:solidFill>
+                  <a:srgbClr val="404040"/>
+                </a:solidFill>
+              </a:defRPr>
+            </a:pPr>
+            <a:r>
+              <a:t>│ Customer: Robert Williams | Type: Auto | Amount: $8,500 │</a:t>
+            </a:r>
+          </a:p>
+          <a:p>
+            <a:pPr lvl="1">
+              <a:spcBef>
+                <a:spcPts val="400"/>
+              </a:spcBef>
+              <a:spcAft>
+                <a:spcPts val="400"/>
+              </a:spcAft>
+              <a:defRPr sz="1400">
+                <a:solidFill>
+                  <a:srgbClr val="404040"/>
+                </a:solidFill>
+              </a:defRPr>
+            </a:pPr>
+            <a:r>
+              <a:t>└─────────────────────────────────────────────────────────┘</a:t>
+            </a:r>
+          </a:p>
+          <a:p>
+            <a:pPr lvl="1">
+              <a:spcBef>
+                <a:spcPts val="400"/>
+              </a:spcBef>
+              <a:spcAft>
+                <a:spcPts val="400"/>
+              </a:spcAft>
+              <a:defRPr sz="1400">
+                <a:solidFill>
+                  <a:srgbClr val="404040"/>
+                </a:solidFill>
+              </a:defRPr>
+            </a:pPr>
+            <a:r>
+              <a:t>📊 ASSESSMENT SCORES:</a:t>
+            </a:r>
+          </a:p>
+          <a:p>
+            <a:pPr lvl="1">
+              <a:spcBef>
+                <a:spcPts val="400"/>
+              </a:spcBef>
+              <a:spcAft>
+                <a:spcPts val="400"/>
+              </a:spcAft>
+              <a:defRPr sz="1400">
+                <a:solidFill>
+                  <a:srgbClr val="404040"/>
+                </a:solidFill>
+              </a:defRPr>
+            </a:pPr>
+            <a:r>
+              <a:t>Final Score: 0.842 ✓ (UNDER REVIEW - Agent synthesis)</a:t>
+            </a:r>
+          </a:p>
+          <a:p>
+            <a:pPr lvl="1">
+              <a:spcBef>
+                <a:spcPts val="400"/>
+              </a:spcBef>
+              <a:spcAft>
+                <a:spcPts val="400"/>
+              </a:spcAft>
+              <a:defRPr sz="1400">
+                <a:solidFill>
+                  <a:srgbClr val="404040"/>
+                </a:solidFill>
+              </a:defRPr>
+            </a:pPr>
+            <a:r>
+              <a:t>Compliance Score: 0.740 ✓ (Passed IRDAI/SOX/AML)</a:t>
+            </a:r>
+          </a:p>
+          <a:p>
+            <a:pPr lvl="1">
+              <a:spcBef>
+                <a:spcPts val="400"/>
+              </a:spcBef>
+              <a:spcAft>
+                <a:spcPts val="400"/>
+              </a:spcAft>
+              <a:defRPr sz="1400">
+                <a:solidFill>
+                  <a:srgbClr val="404040"/>
+                </a:solidFill>
+              </a:defRPr>
+            </a:pPr>
+            <a:r>
+              <a:t>Fraud Score: 0.000 ✓ (No fraud indicators)</a:t>
+            </a:r>
+          </a:p>
+          <a:p>
+            <a:pPr lvl="1">
+              <a:spcBef>
+                <a:spcPts val="400"/>
+              </a:spcBef>
+              <a:spcAft>
+                <a:spcPts val="400"/>
+              </a:spcAft>
+              <a:defRPr sz="1400">
+                <a:solidFill>
+                  <a:srgbClr val="404040"/>
+                </a:solidFill>
+              </a:defRPr>
+            </a:pPr>
+            <a:r>
+              <a:t>Risk Score: 0.000 ✓ (Low risk profile)</a:t>
+            </a:r>
+          </a:p>
+          <a:p>
+            <a:pPr lvl="1">
+              <a:spcBef>
+                <a:spcPts val="400"/>
+              </a:spcBef>
+              <a:spcAft>
+                <a:spcPts val="400"/>
+              </a:spcAft>
+              <a:defRPr sz="1400">
+                <a:solidFill>
+                  <a:srgbClr val="404040"/>
+                </a:solidFill>
+              </a:defRPr>
+            </a:pPr>
+            <a:r>
+              <a:t>Identity Confidence: 0.500 ✓ (Verified)</a:t>
+            </a:r>
+          </a:p>
+          <a:p>
+            <a:pPr lvl="1">
+              <a:spcBef>
+                <a:spcPts val="400"/>
+              </a:spcBef>
+              <a:spcAft>
+                <a:spcPts val="400"/>
+              </a:spcAft>
+              <a:defRPr sz="1400">
+                <a:solidFill>
+                  <a:srgbClr val="404040"/>
+                </a:solidFill>
+              </a:defRPr>
+            </a:pPr>
+            <a:r>
+              <a:t>✅ COMPLIANCE STATUS: PASS</a:t>
+            </a:r>
+          </a:p>
+          <a:p>
+            <a:pPr lvl="1">
+              <a:spcBef>
+                <a:spcPts val="400"/>
+              </a:spcBef>
+              <a:spcAft>
+                <a:spcPts val="400"/>
+              </a:spcAft>
+              <a:defRPr sz="1400">
+                <a:solidFill>
+                  <a:srgbClr val="404040"/>
+                </a:solidFill>
+              </a:defRPr>
+            </a:pPr>
+            <a:r>
+              <a:t>✓ IRDAI Validation: PASS</a:t>
+            </a:r>
+          </a:p>
+          <a:p>
+            <a:pPr lvl="1">
+              <a:spcBef>
+                <a:spcPts val="400"/>
+              </a:spcBef>
+              <a:spcAft>
+                <a:spcPts val="400"/>
+              </a:spcAft>
+              <a:defRPr sz="1400">
+                <a:solidFill>
+                  <a:srgbClr val="404040"/>
+                </a:solidFill>
+              </a:defRPr>
+            </a:pPr>
+            <a:r>
+              <a:t>✓ SOX Compliance: PASS</a:t>
+            </a:r>
+          </a:p>
+          <a:p>
+            <a:pPr lvl="1">
+              <a:spcBef>
+                <a:spcPts val="400"/>
+              </a:spcBef>
+              <a:spcAft>
+                <a:spcPts val="400"/>
+              </a:spcAft>
+              <a:defRPr sz="1400">
+                <a:solidFill>
+                  <a:srgbClr val="404040"/>
+                </a:solidFill>
+              </a:defRPr>
+            </a:pPr>
+            <a:r>
+              <a:t>✓ AML/KYC: PASS</a:t>
+            </a:r>
+          </a:p>
+          <a:p>
+            <a:pPr lvl="1">
+              <a:spcBef>
+                <a:spcPts val="400"/>
+              </a:spcBef>
+              <a:spcAft>
+                <a:spcPts val="400"/>
+              </a:spcAft>
+              <a:defRPr sz="1400">
+                <a:solidFill>
+                  <a:srgbClr val="404040"/>
+                </a:solidFill>
+              </a:defRPr>
+            </a:pPr>
+            <a:r>
+              <a:t>✓ Coverage Validation: PASS</a:t>
+            </a:r>
+          </a:p>
+          <a:p>
+            <a:pPr lvl="1">
+              <a:spcBef>
+                <a:spcPts val="400"/>
+              </a:spcBef>
+              <a:spcAft>
+                <a:spcPts val="400"/>
+              </a:spcAft>
+              <a:defRPr sz="1400">
+                <a:solidFill>
+                  <a:srgbClr val="404040"/>
+                </a:solidFill>
+              </a:defRPr>
+            </a:pPr>
+            <a:r>
+              <a:t>⏱️ PROCESSING TIMELINE:</a:t>
+            </a:r>
+          </a:p>
+          <a:p>
+            <a:pPr lvl="1">
+              <a:spcBef>
+                <a:spcPts val="400"/>
+              </a:spcBef>
+              <a:spcAft>
+                <a:spcPts val="400"/>
+              </a:spcAft>
+              <a:defRPr sz="1400">
+                <a:solidFill>
+                  <a:srgbClr val="404040"/>
+                </a:solidFill>
+              </a:defRPr>
+            </a:pPr>
+            <a:r>
+              <a:t>Submitted: 6/14/2026, 7:05:46 AM</a:t>
+            </a:r>
+          </a:p>
+          <a:p>
+            <a:pPr lvl="1">
+              <a:spcBef>
+                <a:spcPts val="400"/>
+              </a:spcBef>
+              <a:spcAft>
+                <a:spcPts val="400"/>
+              </a:spcAft>
+              <a:defRPr sz="1400">
+                <a:solidFill>
+                  <a:srgbClr val="404040"/>
+                </a:solidFill>
+              </a:defRPr>
+            </a:pPr>
+            <a:r>
+              <a:t>Assessed: 6/14/2026, 7:09:24 AM</a:t>
+            </a:r>
+          </a:p>
+          <a:p>
+            <a:pPr lvl="1">
+              <a:spcBef>
+                <a:spcPts val="400"/>
+              </a:spcBef>
+              <a:spcAft>
+                <a:spcPts val="400"/>
+              </a:spcAft>
+              <a:defRPr sz="1400">
+                <a:solidFill>
+                  <a:srgbClr val="404040"/>
+                </a:solidFill>
+              </a:defRPr>
+            </a:pPr>
+            <a:r>
+              <a:t>Duration: ~3.5 minutes (agents + hooks)</a:t>
+            </a:r>
+          </a:p>
+          <a:p>
+            <a:pPr lvl="1">
+              <a:spcBef>
+                <a:spcPts val="400"/>
+              </a:spcBef>
+              <a:spcAft>
+                <a:spcPts val="400"/>
+              </a:spcAft>
+              <a:defRPr sz="1400">
+                <a:solidFill>
+                  <a:srgbClr val="404040"/>
+                </a:solidFill>
+              </a:defRPr>
+            </a:pPr>
+            <a:r>
+              <a:t>Status: UNDER REVIEW → Ready for manual verification (optional)</a:t>
+            </a:r>
+          </a:p>
+        </p:txBody>
+      </p:sp>
+    </p:spTree>
+  </p:cSld>
+  <p:clrMapOvr>
+    <a:masterClrMapping/>
+  </p:clrMapOvr>
+</p:sld>
+</file>
+
+<file path=ppt/slides/slide28.xml><?xml version="1.0" encoding="utf-8"?>
 <p:sld xmlns:a="http://schemas.openxmlformats.org/drawingml/2006/main" xmlns:p="http://schemas.openxmlformats.org/presentationml/2006/main" xmlns:r="http://schemas.openxmlformats.org/officeDocument/2006/relationships">
   <p:cSld>
     <p:bg>

</xml_diff>

<commit_message>
Add screenshot-embedded presentation (29 slides) with visual guided process walkthrough showing dashboard, form submission, claims processing, assessment results, and API documentation
</commit_message>
<xml_diff>
--- a/docs/Insurance_Claim_Assessment_Presentation.pptx
+++ b/docs/Insurance_Claim_Assessment_Presentation.pptx
@@ -33,6 +33,7 @@
     <p:sldId id="281" r:id="rId32"/>
     <p:sldId id="282" r:id="rId33"/>
     <p:sldId id="283" r:id="rId34"/>
+    <p:sldId id="284" r:id="rId35"/>
   </p:sldIdLst>
   <p:sldSz cx="9144000" cy="6858000" type="screen4x3"/>
   <p:notesSz cx="6858000" cy="9144000"/>
@@ -9538,814 +9539,52 @@
           <a:lstStyle/>
           <a:p>
             <a:pPr>
-              <a:defRPr sz="3200" b="1">
+              <a:defRPr sz="2800" b="1">
                 <a:solidFill>
                   <a:srgbClr val="FFFFFF"/>
                 </a:solidFill>
               </a:defRPr>
             </a:pPr>
             <a:r>
-              <a:t>Slide 24: Assessment Pipeline - Visual Flow</a:t>
-            </a:r>
-          </a:p>
-        </p:txBody>
-      </p:sp>
-      <p:sp>
-        <p:nvSpPr>
-          <p:cNvPr id="4" name="Rounded Rectangle 3"/>
-          <p:cNvSpPr/>
+              <a:t>Slide 24: Step 1 - Submit Insurance Claim Form</a:t>
+            </a:r>
+          </a:p>
+        </p:txBody>
+      </p:sp>
+      <p:pic>
+        <p:nvPicPr>
+          <p:cNvPr id="4" name="Picture 3" descr="screenshot_submit_claim.png"/>
+          <p:cNvPicPr>
+            <a:picLocks noChangeAspect="1"/>
+          </p:cNvPicPr>
           <p:nvPr/>
-        </p:nvSpPr>
+        </p:nvPicPr>
+        <p:blipFill>
+          <a:blip r:embed="rId2"/>
+          <a:stretch>
+            <a:fillRect/>
+          </a:stretch>
+        </p:blipFill>
         <p:spPr>
           <a:xfrm>
-            <a:off x="274320" y="1828800"/>
-            <a:ext cx="822960" cy="548640"/>
+            <a:off x="182880" y="822960"/>
+            <a:ext cx="8778240" cy="6583680"/>
           </a:xfrm>
-          <a:prstGeom prst="roundRect">
+          <a:prstGeom prst="rect">
             <a:avLst/>
           </a:prstGeom>
-          <a:solidFill>
-            <a:srgbClr val="FF7F27"/>
-          </a:solidFill>
-          <a:ln>
-            <a:solidFill>
-              <a:srgbClr val="19376D"/>
-            </a:solidFill>
-          </a:ln>
         </p:spPr>
-        <p:style>
-          <a:lnRef idx="1">
-            <a:schemeClr val="accent1"/>
-          </a:lnRef>
-          <a:fillRef idx="3">
-            <a:schemeClr val="accent1"/>
-          </a:fillRef>
-          <a:effectRef idx="2">
-            <a:schemeClr val="accent1"/>
-          </a:effectRef>
-          <a:fontRef idx="minor">
-            <a:schemeClr val="lt1"/>
-          </a:fontRef>
-        </p:style>
-        <p:txBody>
-          <a:bodyPr rtlCol="0" anchor="ctr"/>
-          <a:lstStyle/>
-          <a:p>
-            <a:pPr algn="ctr">
-              <a:defRPr sz="900" b="1">
-                <a:solidFill>
-                  <a:srgbClr val="FFFFFF"/>
-                </a:solidFill>
-              </a:defRPr>
-            </a:pPr>
-            <a:r>
-              <a:t>INPUT</a:t>
-            </a:r>
-          </a:p>
-        </p:txBody>
-      </p:sp>
-      <p:cxnSp>
-        <p:nvCxnSpPr>
-          <p:cNvPr id="5" name="Connector 4"/>
-          <p:cNvCxnSpPr/>
+      </p:pic>
+      <p:sp>
+        <p:nvSpPr>
+          <p:cNvPr id="5" name="TextBox 4"/>
+          <p:cNvSpPr txBox="1"/>
           <p:nvPr/>
-        </p:nvCxnSpPr>
+        </p:nvSpPr>
         <p:spPr>
           <a:xfrm>
-            <a:off x="1097280" y="2103120.0"/>
-            <a:ext cx="137160" cy="0.0"/>
-          </a:xfrm>
-          <a:prstGeom prst="line">
-            <a:avLst/>
-          </a:prstGeom>
-          <a:ln>
-            <a:solidFill>
-              <a:srgbClr val="404040"/>
-            </a:solidFill>
-          </a:ln>
-        </p:spPr>
-        <p:style>
-          <a:lnRef idx="2">
-            <a:schemeClr val="accent1"/>
-          </a:lnRef>
-          <a:fillRef idx="0">
-            <a:schemeClr val="accent1"/>
-          </a:fillRef>
-          <a:effectRef idx="1">
-            <a:schemeClr val="accent1"/>
-          </a:effectRef>
-          <a:fontRef idx="minor">
-            <a:schemeClr val="tx1"/>
-          </a:fontRef>
-        </p:style>
-      </p:cxnSp>
-      <p:sp>
-        <p:nvSpPr>
-          <p:cNvPr id="6" name="Rounded Rectangle 5"/>
-          <p:cNvSpPr/>
-          <p:nvPr/>
-        </p:nvSpPr>
-        <p:spPr>
-          <a:xfrm>
-            <a:off x="1234440" y="1828800"/>
-            <a:ext cx="822960" cy="548640"/>
-          </a:xfrm>
-          <a:prstGeom prst="roundRect">
-            <a:avLst/>
-          </a:prstGeom>
-          <a:solidFill>
-            <a:srgbClr val="3B5998"/>
-          </a:solidFill>
-          <a:ln>
-            <a:solidFill>
-              <a:srgbClr val="19376D"/>
-            </a:solidFill>
-          </a:ln>
-        </p:spPr>
-        <p:style>
-          <a:lnRef idx="1">
-            <a:schemeClr val="accent1"/>
-          </a:lnRef>
-          <a:fillRef idx="3">
-            <a:schemeClr val="accent1"/>
-          </a:fillRef>
-          <a:effectRef idx="2">
-            <a:schemeClr val="accent1"/>
-          </a:effectRef>
-          <a:fontRef idx="minor">
-            <a:schemeClr val="lt1"/>
-          </a:fontRef>
-        </p:style>
-        <p:txBody>
-          <a:bodyPr rtlCol="0" anchor="ctr"/>
-          <a:lstStyle/>
-          <a:p>
-            <a:pPr algn="ctr">
-              <a:defRPr sz="900" b="1">
-                <a:solidFill>
-                  <a:srgbClr val="FFFFFF"/>
-                </a:solidFill>
-              </a:defRPr>
-            </a:pPr>
-            <a:r>
-              <a:t>Validation</a:t>
-            </a:r>
-          </a:p>
-        </p:txBody>
-      </p:sp>
-      <p:cxnSp>
-        <p:nvCxnSpPr>
-          <p:cNvPr id="7" name="Connector 6"/>
-          <p:cNvCxnSpPr/>
-          <p:nvPr/>
-        </p:nvCxnSpPr>
-        <p:spPr>
-          <a:xfrm>
-            <a:off x="2057400" y="2103120.0"/>
-            <a:ext cx="137160" cy="0.0"/>
-          </a:xfrm>
-          <a:prstGeom prst="line">
-            <a:avLst/>
-          </a:prstGeom>
-          <a:ln>
-            <a:solidFill>
-              <a:srgbClr val="404040"/>
-            </a:solidFill>
-          </a:ln>
-        </p:spPr>
-        <p:style>
-          <a:lnRef idx="2">
-            <a:schemeClr val="accent1"/>
-          </a:lnRef>
-          <a:fillRef idx="0">
-            <a:schemeClr val="accent1"/>
-          </a:fillRef>
-          <a:effectRef idx="1">
-            <a:schemeClr val="accent1"/>
-          </a:effectRef>
-          <a:fontRef idx="minor">
-            <a:schemeClr val="tx1"/>
-          </a:fontRef>
-        </p:style>
-      </p:cxnSp>
-      <p:sp>
-        <p:nvSpPr>
-          <p:cNvPr id="8" name="Rounded Rectangle 7"/>
-          <p:cNvSpPr/>
-          <p:nvPr/>
-        </p:nvSpPr>
-        <p:spPr>
-          <a:xfrm>
-            <a:off x="2194560" y="1828800"/>
-            <a:ext cx="822960" cy="548640"/>
-          </a:xfrm>
-          <a:prstGeom prst="roundRect">
-            <a:avLst/>
-          </a:prstGeom>
-          <a:solidFill>
-            <a:srgbClr val="3B5998"/>
-          </a:solidFill>
-          <a:ln>
-            <a:solidFill>
-              <a:srgbClr val="19376D"/>
-            </a:solidFill>
-          </a:ln>
-        </p:spPr>
-        <p:style>
-          <a:lnRef idx="1">
-            <a:schemeClr val="accent1"/>
-          </a:lnRef>
-          <a:fillRef idx="3">
-            <a:schemeClr val="accent1"/>
-          </a:fillRef>
-          <a:effectRef idx="2">
-            <a:schemeClr val="accent1"/>
-          </a:effectRef>
-          <a:fontRef idx="minor">
-            <a:schemeClr val="lt1"/>
-          </a:fontRef>
-        </p:style>
-        <p:txBody>
-          <a:bodyPr rtlCol="0" anchor="ctr"/>
-          <a:lstStyle/>
-          <a:p>
-            <a:pPr algn="ctr">
-              <a:defRPr sz="900" b="1">
-                <a:solidFill>
-                  <a:srgbClr val="FFFFFF"/>
-                </a:solidFill>
-              </a:defRPr>
-            </a:pPr>
-            <a:r>
-              <a:t>Security</a:t>
-            </a:r>
-          </a:p>
-        </p:txBody>
-      </p:sp>
-      <p:cxnSp>
-        <p:nvCxnSpPr>
-          <p:cNvPr id="9" name="Connector 8"/>
-          <p:cNvCxnSpPr/>
-          <p:nvPr/>
-        </p:nvCxnSpPr>
-        <p:spPr>
-          <a:xfrm>
-            <a:off x="3017520" y="2103120.0"/>
-            <a:ext cx="137160" cy="0.0"/>
-          </a:xfrm>
-          <a:prstGeom prst="line">
-            <a:avLst/>
-          </a:prstGeom>
-          <a:ln>
-            <a:solidFill>
-              <a:srgbClr val="404040"/>
-            </a:solidFill>
-          </a:ln>
-        </p:spPr>
-        <p:style>
-          <a:lnRef idx="2">
-            <a:schemeClr val="accent1"/>
-          </a:lnRef>
-          <a:fillRef idx="0">
-            <a:schemeClr val="accent1"/>
-          </a:fillRef>
-          <a:effectRef idx="1">
-            <a:schemeClr val="accent1"/>
-          </a:effectRef>
-          <a:fontRef idx="minor">
-            <a:schemeClr val="tx1"/>
-          </a:fontRef>
-        </p:style>
-      </p:cxnSp>
-      <p:sp>
-        <p:nvSpPr>
-          <p:cNvPr id="10" name="Rounded Rectangle 9"/>
-          <p:cNvSpPr/>
-          <p:nvPr/>
-        </p:nvSpPr>
-        <p:spPr>
-          <a:xfrm>
-            <a:off x="3154680" y="1828800"/>
-            <a:ext cx="822960" cy="548640"/>
-          </a:xfrm>
-          <a:prstGeom prst="roundRect">
-            <a:avLst/>
-          </a:prstGeom>
-          <a:solidFill>
-            <a:srgbClr val="4CAF50"/>
-          </a:solidFill>
-          <a:ln>
-            <a:solidFill>
-              <a:srgbClr val="19376D"/>
-            </a:solidFill>
-          </a:ln>
-        </p:spPr>
-        <p:style>
-          <a:lnRef idx="1">
-            <a:schemeClr val="accent1"/>
-          </a:lnRef>
-          <a:fillRef idx="3">
-            <a:schemeClr val="accent1"/>
-          </a:fillRef>
-          <a:effectRef idx="2">
-            <a:schemeClr val="accent1"/>
-          </a:effectRef>
-          <a:fontRef idx="minor">
-            <a:schemeClr val="lt1"/>
-          </a:fontRef>
-        </p:style>
-        <p:txBody>
-          <a:bodyPr rtlCol="0" anchor="ctr"/>
-          <a:lstStyle/>
-          <a:p>
-            <a:pPr algn="ctr">
-              <a:defRPr sz="900" b="1">
-                <a:solidFill>
-                  <a:srgbClr val="FFFFFF"/>
-                </a:solidFill>
-              </a:defRPr>
-            </a:pPr>
-            <a:r>
-              <a:t>Customer</a:t>
-            </a:r>
-            <a:br/>
-            <a:r>
-              <a:t>Agent</a:t>
-            </a:r>
-          </a:p>
-        </p:txBody>
-      </p:sp>
-      <p:cxnSp>
-        <p:nvCxnSpPr>
-          <p:cNvPr id="11" name="Connector 10"/>
-          <p:cNvCxnSpPr/>
-          <p:nvPr/>
-        </p:nvCxnSpPr>
-        <p:spPr>
-          <a:xfrm>
-            <a:off x="3977640" y="2103120.0"/>
-            <a:ext cx="137160" cy="0.0"/>
-          </a:xfrm>
-          <a:prstGeom prst="line">
-            <a:avLst/>
-          </a:prstGeom>
-          <a:ln>
-            <a:solidFill>
-              <a:srgbClr val="404040"/>
-            </a:solidFill>
-          </a:ln>
-        </p:spPr>
-        <p:style>
-          <a:lnRef idx="2">
-            <a:schemeClr val="accent1"/>
-          </a:lnRef>
-          <a:fillRef idx="0">
-            <a:schemeClr val="accent1"/>
-          </a:fillRef>
-          <a:effectRef idx="1">
-            <a:schemeClr val="accent1"/>
-          </a:effectRef>
-          <a:fontRef idx="minor">
-            <a:schemeClr val="tx1"/>
-          </a:fontRef>
-        </p:style>
-      </p:cxnSp>
-      <p:sp>
-        <p:nvSpPr>
-          <p:cNvPr id="12" name="Rounded Rectangle 11"/>
-          <p:cNvSpPr/>
-          <p:nvPr/>
-        </p:nvSpPr>
-        <p:spPr>
-          <a:xfrm>
-            <a:off x="4114800" y="1828800"/>
-            <a:ext cx="822960" cy="548640"/>
-          </a:xfrm>
-          <a:prstGeom prst="roundRect">
-            <a:avLst/>
-          </a:prstGeom>
-          <a:solidFill>
-            <a:srgbClr val="4CAF50"/>
-          </a:solidFill>
-          <a:ln>
-            <a:solidFill>
-              <a:srgbClr val="19376D"/>
-            </a:solidFill>
-          </a:ln>
-        </p:spPr>
-        <p:style>
-          <a:lnRef idx="1">
-            <a:schemeClr val="accent1"/>
-          </a:lnRef>
-          <a:fillRef idx="3">
-            <a:schemeClr val="accent1"/>
-          </a:fillRef>
-          <a:effectRef idx="2">
-            <a:schemeClr val="accent1"/>
-          </a:effectRef>
-          <a:fontRef idx="minor">
-            <a:schemeClr val="lt1"/>
-          </a:fontRef>
-        </p:style>
-        <p:txBody>
-          <a:bodyPr rtlCol="0" anchor="ctr"/>
-          <a:lstStyle/>
-          <a:p>
-            <a:pPr algn="ctr">
-              <a:defRPr sz="900" b="1">
-                <a:solidFill>
-                  <a:srgbClr val="FFFFFF"/>
-                </a:solidFill>
-              </a:defRPr>
-            </a:pPr>
-            <a:r>
-              <a:t>Knowledge</a:t>
-            </a:r>
-            <a:br/>
-            <a:r>
-              <a:t>Agent</a:t>
-            </a:r>
-          </a:p>
-        </p:txBody>
-      </p:sp>
-      <p:cxnSp>
-        <p:nvCxnSpPr>
-          <p:cNvPr id="13" name="Connector 12"/>
-          <p:cNvCxnSpPr/>
-          <p:nvPr/>
-        </p:nvCxnSpPr>
-        <p:spPr>
-          <a:xfrm>
-            <a:off x="4937760" y="2103120.0"/>
-            <a:ext cx="137160" cy="0.0"/>
-          </a:xfrm>
-          <a:prstGeom prst="line">
-            <a:avLst/>
-          </a:prstGeom>
-          <a:ln>
-            <a:solidFill>
-              <a:srgbClr val="404040"/>
-            </a:solidFill>
-          </a:ln>
-        </p:spPr>
-        <p:style>
-          <a:lnRef idx="2">
-            <a:schemeClr val="accent1"/>
-          </a:lnRef>
-          <a:fillRef idx="0">
-            <a:schemeClr val="accent1"/>
-          </a:fillRef>
-          <a:effectRef idx="1">
-            <a:schemeClr val="accent1"/>
-          </a:effectRef>
-          <a:fontRef idx="minor">
-            <a:schemeClr val="tx1"/>
-          </a:fontRef>
-        </p:style>
-      </p:cxnSp>
-      <p:sp>
-        <p:nvSpPr>
-          <p:cNvPr id="14" name="Rounded Rectangle 13"/>
-          <p:cNvSpPr/>
-          <p:nvPr/>
-        </p:nvSpPr>
-        <p:spPr>
-          <a:xfrm>
-            <a:off x="5074920" y="1828800"/>
-            <a:ext cx="822960" cy="548640"/>
-          </a:xfrm>
-          <a:prstGeom prst="roundRect">
-            <a:avLst/>
-          </a:prstGeom>
-          <a:solidFill>
-            <a:srgbClr val="4CAF50"/>
-          </a:solidFill>
-          <a:ln>
-            <a:solidFill>
-              <a:srgbClr val="19376D"/>
-            </a:solidFill>
-          </a:ln>
-        </p:spPr>
-        <p:style>
-          <a:lnRef idx="1">
-            <a:schemeClr val="accent1"/>
-          </a:lnRef>
-          <a:fillRef idx="3">
-            <a:schemeClr val="accent1"/>
-          </a:fillRef>
-          <a:effectRef idx="2">
-            <a:schemeClr val="accent1"/>
-          </a:effectRef>
-          <a:fontRef idx="minor">
-            <a:schemeClr val="lt1"/>
-          </a:fontRef>
-        </p:style>
-        <p:txBody>
-          <a:bodyPr rtlCol="0" anchor="ctr"/>
-          <a:lstStyle/>
-          <a:p>
-            <a:pPr algn="ctr">
-              <a:defRPr sz="900" b="1">
-                <a:solidFill>
-                  <a:srgbClr val="FFFFFF"/>
-                </a:solidFill>
-              </a:defRPr>
-            </a:pPr>
-            <a:r>
-              <a:t>Compliance</a:t>
-            </a:r>
-            <a:br/>
-            <a:r>
-              <a:t>&amp; Risk</a:t>
-            </a:r>
-          </a:p>
-        </p:txBody>
-      </p:sp>
-      <p:cxnSp>
-        <p:nvCxnSpPr>
-          <p:cNvPr id="15" name="Connector 14"/>
-          <p:cNvCxnSpPr/>
-          <p:nvPr/>
-        </p:nvCxnSpPr>
-        <p:spPr>
-          <a:xfrm>
-            <a:off x="5897880" y="2103120.0"/>
-            <a:ext cx="137160" cy="0.0"/>
-          </a:xfrm>
-          <a:prstGeom prst="line">
-            <a:avLst/>
-          </a:prstGeom>
-          <a:ln>
-            <a:solidFill>
-              <a:srgbClr val="404040"/>
-            </a:solidFill>
-          </a:ln>
-        </p:spPr>
-        <p:style>
-          <a:lnRef idx="2">
-            <a:schemeClr val="accent1"/>
-          </a:lnRef>
-          <a:fillRef idx="0">
-            <a:schemeClr val="accent1"/>
-          </a:fillRef>
-          <a:effectRef idx="1">
-            <a:schemeClr val="accent1"/>
-          </a:effectRef>
-          <a:fontRef idx="minor">
-            <a:schemeClr val="tx1"/>
-          </a:fontRef>
-        </p:style>
-      </p:cxnSp>
-      <p:sp>
-        <p:nvSpPr>
-          <p:cNvPr id="16" name="Rounded Rectangle 15"/>
-          <p:cNvSpPr/>
-          <p:nvPr/>
-        </p:nvSpPr>
-        <p:spPr>
-          <a:xfrm>
-            <a:off x="6035040" y="1828800"/>
-            <a:ext cx="822960" cy="548640"/>
-          </a:xfrm>
-          <a:prstGeom prst="roundRect">
-            <a:avLst/>
-          </a:prstGeom>
-          <a:solidFill>
-            <a:srgbClr val="4CAF50"/>
-          </a:solidFill>
-          <a:ln>
-            <a:solidFill>
-              <a:srgbClr val="19376D"/>
-            </a:solidFill>
-          </a:ln>
-        </p:spPr>
-        <p:style>
-          <a:lnRef idx="1">
-            <a:schemeClr val="accent1"/>
-          </a:lnRef>
-          <a:fillRef idx="3">
-            <a:schemeClr val="accent1"/>
-          </a:fillRef>
-          <a:effectRef idx="2">
-            <a:schemeClr val="accent1"/>
-          </a:effectRef>
-          <a:fontRef idx="minor">
-            <a:schemeClr val="lt1"/>
-          </a:fontRef>
-        </p:style>
-        <p:txBody>
-          <a:bodyPr rtlCol="0" anchor="ctr"/>
-          <a:lstStyle/>
-          <a:p>
-            <a:pPr algn="ctr">
-              <a:defRPr sz="900" b="1">
-                <a:solidFill>
-                  <a:srgbClr val="FFFFFF"/>
-                </a:solidFill>
-              </a:defRPr>
-            </a:pPr>
-            <a:r>
-              <a:t>Decision</a:t>
-            </a:r>
-            <a:br/>
-            <a:r>
-              <a:t>Agent</a:t>
-            </a:r>
-          </a:p>
-        </p:txBody>
-      </p:sp>
-      <p:cxnSp>
-        <p:nvCxnSpPr>
-          <p:cNvPr id="17" name="Connector 16"/>
-          <p:cNvCxnSpPr/>
-          <p:nvPr/>
-        </p:nvCxnSpPr>
-        <p:spPr>
-          <a:xfrm>
-            <a:off x="6858000" y="2103120.0"/>
-            <a:ext cx="137160" cy="0.0"/>
-          </a:xfrm>
-          <a:prstGeom prst="line">
-            <a:avLst/>
-          </a:prstGeom>
-          <a:ln>
-            <a:solidFill>
-              <a:srgbClr val="404040"/>
-            </a:solidFill>
-          </a:ln>
-        </p:spPr>
-        <p:style>
-          <a:lnRef idx="2">
-            <a:schemeClr val="accent1"/>
-          </a:lnRef>
-          <a:fillRef idx="0">
-            <a:schemeClr val="accent1"/>
-          </a:fillRef>
-          <a:effectRef idx="1">
-            <a:schemeClr val="accent1"/>
-          </a:effectRef>
-          <a:fontRef idx="minor">
-            <a:schemeClr val="tx1"/>
-          </a:fontRef>
-        </p:style>
-      </p:cxnSp>
-      <p:sp>
-        <p:nvSpPr>
-          <p:cNvPr id="18" name="Rounded Rectangle 17"/>
-          <p:cNvSpPr/>
-          <p:nvPr/>
-        </p:nvSpPr>
-        <p:spPr>
-          <a:xfrm>
-            <a:off x="6995160" y="1828800"/>
-            <a:ext cx="822960" cy="548640"/>
-          </a:xfrm>
-          <a:prstGeom prst="roundRect">
-            <a:avLst/>
-          </a:prstGeom>
-          <a:solidFill>
-            <a:srgbClr val="4CAF50"/>
-          </a:solidFill>
-          <a:ln>
-            <a:solidFill>
-              <a:srgbClr val="19376D"/>
-            </a:solidFill>
-          </a:ln>
-        </p:spPr>
-        <p:style>
-          <a:lnRef idx="1">
-            <a:schemeClr val="accent1"/>
-          </a:lnRef>
-          <a:fillRef idx="3">
-            <a:schemeClr val="accent1"/>
-          </a:fillRef>
-          <a:effectRef idx="2">
-            <a:schemeClr val="accent1"/>
-          </a:effectRef>
-          <a:fontRef idx="minor">
-            <a:schemeClr val="lt1"/>
-          </a:fontRef>
-        </p:style>
-        <p:txBody>
-          <a:bodyPr rtlCol="0" anchor="ctr"/>
-          <a:lstStyle/>
-          <a:p>
-            <a:pPr algn="ctr">
-              <a:defRPr sz="900" b="1">
-                <a:solidFill>
-                  <a:srgbClr val="FFFFFF"/>
-                </a:solidFill>
-              </a:defRPr>
-            </a:pPr>
-            <a:r>
-              <a:t>Audit</a:t>
-            </a:r>
-            <a:br/>
-            <a:r>
-              <a:t>Agent</a:t>
-            </a:r>
-          </a:p>
-        </p:txBody>
-      </p:sp>
-      <p:cxnSp>
-        <p:nvCxnSpPr>
-          <p:cNvPr id="19" name="Connector 18"/>
-          <p:cNvCxnSpPr/>
-          <p:nvPr/>
-        </p:nvCxnSpPr>
-        <p:spPr>
-          <a:xfrm>
-            <a:off x="7818120" y="2103120.0"/>
-            <a:ext cx="137160" cy="0.0"/>
-          </a:xfrm>
-          <a:prstGeom prst="line">
-            <a:avLst/>
-          </a:prstGeom>
-          <a:ln>
-            <a:solidFill>
-              <a:srgbClr val="404040"/>
-            </a:solidFill>
-          </a:ln>
-        </p:spPr>
-        <p:style>
-          <a:lnRef idx="2">
-            <a:schemeClr val="accent1"/>
-          </a:lnRef>
-          <a:fillRef idx="0">
-            <a:schemeClr val="accent1"/>
-          </a:fillRef>
-          <a:effectRef idx="1">
-            <a:schemeClr val="accent1"/>
-          </a:effectRef>
-          <a:fontRef idx="minor">
-            <a:schemeClr val="tx1"/>
-          </a:fontRef>
-        </p:style>
-      </p:cxnSp>
-      <p:sp>
-        <p:nvSpPr>
-          <p:cNvPr id="20" name="Rounded Rectangle 19"/>
-          <p:cNvSpPr/>
-          <p:nvPr/>
-        </p:nvSpPr>
-        <p:spPr>
-          <a:xfrm>
-            <a:off x="7955280" y="1828800"/>
-            <a:ext cx="822960" cy="548640"/>
-          </a:xfrm>
-          <a:prstGeom prst="roundRect">
-            <a:avLst/>
-          </a:prstGeom>
-          <a:solidFill>
-            <a:srgbClr val="FF7F27"/>
-          </a:solidFill>
-          <a:ln>
-            <a:solidFill>
-              <a:srgbClr val="19376D"/>
-            </a:solidFill>
-          </a:ln>
-        </p:spPr>
-        <p:style>
-          <a:lnRef idx="1">
-            <a:schemeClr val="accent1"/>
-          </a:lnRef>
-          <a:fillRef idx="3">
-            <a:schemeClr val="accent1"/>
-          </a:fillRef>
-          <a:effectRef idx="2">
-            <a:schemeClr val="accent1"/>
-          </a:effectRef>
-          <a:fontRef idx="minor">
-            <a:schemeClr val="lt1"/>
-          </a:fontRef>
-        </p:style>
-        <p:txBody>
-          <a:bodyPr rtlCol="0" anchor="ctr"/>
-          <a:lstStyle/>
-          <a:p>
-            <a:pPr algn="ctr">
-              <a:defRPr sz="900" b="1">
-                <a:solidFill>
-                  <a:srgbClr val="FFFFFF"/>
-                </a:solidFill>
-              </a:defRPr>
-            </a:pPr>
-            <a:r>
-              <a:t>OUTPUT</a:t>
-            </a:r>
-          </a:p>
-        </p:txBody>
-      </p:sp>
-      <p:sp>
-        <p:nvSpPr>
-          <p:cNvPr id="21" name="TextBox 20"/>
-          <p:cNvSpPr txBox="1"/>
-          <p:nvPr/>
-        </p:nvSpPr>
-        <p:spPr>
-          <a:xfrm>
-            <a:off x="457200" y="2926080"/>
-            <a:ext cx="8229600" cy="3474720"/>
+            <a:off x="457200" y="6217920"/>
+            <a:ext cx="8229600" cy="731520"/>
           </a:xfrm>
           <a:prstGeom prst="rect">
             <a:avLst/>
@@ -10359,12 +9598,6 @@
           <a:lstStyle/>
           <a:p>
             <a:pPr>
-              <a:spcBef>
-                <a:spcPts val="600"/>
-              </a:spcBef>
-              <a:spcAft>
-                <a:spcPts val="600"/>
-              </a:spcAft>
               <a:defRPr sz="1200">
                 <a:solidFill>
                   <a:srgbClr val="404040"/>
@@ -10372,47 +9605,7 @@
               </a:defRPr>
             </a:pPr>
             <a:r>
-              <a:t>Assessment Pipeline Execution:</a:t>
-            </a:r>
-            <a:br/>
-            <a:r>
-              <a:t>    </a:t>
-            </a:r>
-            <a:br/>
-            <a:r>
-              <a:t>    ✓ InputValidationHook    — Sanitizes and validates claim data</a:t>
-            </a:r>
-            <a:br/>
-            <a:r>
-              <a:t>    ✓ SecurityHook           — Authenticates and authorizes access</a:t>
-            </a:r>
-            <a:br/>
-            <a:r>
-              <a:t>    ✓ CustomerAgent          — Validates identity and extracts claim data</a:t>
-            </a:r>
-            <a:br/>
-            <a:r>
-              <a:t>    ✓ KnowledgeAgent (MCP)   — Retrieves regulatory knowledge and policies</a:t>
-            </a:r>
-            <a:br/>
-            <a:r>
-              <a:t>    ✓ ComplianceAgent        — Validates IRDAI, SOX, AML compliance</a:t>
-            </a:r>
-            <a:br/>
-            <a:r>
-              <a:t>    ✓ RiskAgent              — Performs fraud detection and risk scoring</a:t>
-            </a:r>
-            <a:br/>
-            <a:r>
-              <a:t>    ✓ DecisionAgent          — Synthesizes all outputs and makes recommendation</a:t>
-            </a:r>
-            <a:br/>
-            <a:r>
-              <a:t>    ✓ AuditAgent             — Creates immutable audit trail</a:t>
-            </a:r>
-            <a:br/>
-            <a:r>
-              <a:t>    ✓ OutputValidationHook   — Validates final decision before delivery</a:t>
+              <a:t>User fills out comprehensive claim form with customer info, policy details, claim type, amount, and incident description. Form validates all required fields before submission.</a:t>
             </a:r>
           </a:p>
         </p:txBody>
@@ -10511,28 +9704,52 @@
           <a:lstStyle/>
           <a:p>
             <a:pPr>
-              <a:defRPr sz="3200" b="1">
+              <a:defRPr sz="2800" b="1">
                 <a:solidFill>
                   <a:srgbClr val="FFFFFF"/>
                 </a:solidFill>
               </a:defRPr>
             </a:pPr>
             <a:r>
-              <a:t>Slide 25: Real-Time Dashboard UI</a:t>
-            </a:r>
-          </a:p>
-        </p:txBody>
-      </p:sp>
-      <p:sp>
-        <p:nvSpPr>
-          <p:cNvPr id="4" name="TextBox 3"/>
+              <a:t>Slide 25: Step 2 - Claims Processing Queue</a:t>
+            </a:r>
+          </a:p>
+        </p:txBody>
+      </p:sp>
+      <p:pic>
+        <p:nvPicPr>
+          <p:cNvPr id="4" name="Picture 3" descr="screenshot_claims_list.png"/>
+          <p:cNvPicPr>
+            <a:picLocks noChangeAspect="1"/>
+          </p:cNvPicPr>
+          <p:nvPr/>
+        </p:nvPicPr>
+        <p:blipFill>
+          <a:blip r:embed="rId2"/>
+          <a:stretch>
+            <a:fillRect/>
+          </a:stretch>
+        </p:blipFill>
+        <p:spPr>
+          <a:xfrm>
+            <a:off x="182880" y="822960"/>
+            <a:ext cx="8778240" cy="6583680"/>
+          </a:xfrm>
+          <a:prstGeom prst="rect">
+            <a:avLst/>
+          </a:prstGeom>
+        </p:spPr>
+      </p:pic>
+      <p:sp>
+        <p:nvSpPr>
+          <p:cNvPr id="5" name="TextBox 4"/>
           <p:cNvSpPr txBox="1"/>
           <p:nvPr/>
         </p:nvSpPr>
         <p:spPr>
           <a:xfrm>
-            <a:off x="457200" y="1005840"/>
-            <a:ext cx="8229600" cy="5486400"/>
+            <a:off x="457200" y="6217920"/>
+            <a:ext cx="8229600" cy="731520"/>
           </a:xfrm>
           <a:prstGeom prst="rect">
             <a:avLst/>
@@ -10546,105 +9763,14 @@
           <a:lstStyle/>
           <a:p>
             <a:pPr>
-              <a:spcBef>
-                <a:spcPts val="200"/>
-              </a:spcBef>
-              <a:spcAft>
-                <a:spcPts val="200"/>
-              </a:spcAft>
-              <a:defRPr sz="1100">
-                <a:solidFill>
-                  <a:srgbClr val="404040"/>
-                </a:solidFill>
-                <a:latin typeface="Courier New"/>
-              </a:defRPr>
-            </a:pPr>
-            <a:r>
-              <a:t>🛡️ DASHBOARD FEATURES &amp; REAL-TIME MONITORING</a:t>
-            </a:r>
-            <a:br/>
-            <a:r>
-              <a:t>    </a:t>
-            </a:r>
-            <a:br/>
-            <a:r>
-              <a:t>    ┌─────────────────────────────────────────────────────────────┐</a:t>
-            </a:r>
-            <a:br/>
-            <a:r>
-              <a:t>    │ Total Claims: 2         │ Approved: 0        │ Rejected: 0   │</a:t>
-            </a:r>
-            <a:br/>
-            <a:r>
-              <a:t>    │ Pending Review: 0       │ Avg Fraud Score: 0.0  │ Avg Claim: $6K │</a:t>
-            </a:r>
-            <a:br/>
-            <a:r>
-              <a:t>    └─────────────────────────────────────────────────────────────┘</a:t>
-            </a:r>
-            <a:br/>
-            <a:r>
-              <a:t>    </a:t>
-            </a:r>
-            <a:br/>
-            <a:r>
-              <a:t>    AGENT STATUS (All 6 Operational):</a:t>
-            </a:r>
-            <a:br/>
-            <a:r>
-              <a:t>    ┌──────────────────────────────────────────────────────────────────┐</a:t>
-            </a:r>
-            <a:br/>
-            <a:r>
-              <a:t>    │ ✓ CustomerAgent      — Identity validation &amp; claim extraction    │</a:t>
-            </a:r>
-            <a:br/>
-            <a:r>
-              <a:t>    │ ✓ KnowledgeAgent     — Regulatory knowledge (MCP-enhanced)      │</a:t>
-            </a:r>
-            <a:br/>
-            <a:r>
-              <a:t>    │ ✓ ComplianceAgent    — IRDAI / SOX / AML validation            │</a:t>
-            </a:r>
-            <a:br/>
-            <a:r>
-              <a:t>    │ ✓ RiskAgent          — Fraud detection &amp; risk scoring           │</a:t>
-            </a:r>
-            <a:br/>
-            <a:r>
-              <a:t>    │ ✓ DecisionAgent      — Final assessment synthesis               │</a:t>
-            </a:r>
-            <a:br/>
-            <a:r>
-              <a:t>    │ ✓ AuditAgent         — Immutable audit trail generation         │</a:t>
-            </a:r>
-            <a:br/>
-            <a:r>
-              <a:t>    └──────────────────────────────────────────────────────────────────┘</a:t>
-            </a:r>
-            <a:br/>
-            <a:r>
-              <a:t>    </a:t>
-            </a:r>
-            <a:br/>
-            <a:r>
-              <a:t>    SYSTEM COMPONENTS STATUS:</a:t>
-            </a:r>
-            <a:br/>
-            <a:r>
-              <a:t>    ┓ MCP — RegulatoryKnowledgeBase   ✓ Connected</a:t>
-            </a:r>
-            <a:br/>
-            <a:r>
-              <a:t>    ┓ Database — SQLite + SQLAlchemy  ✓ Healthy</a:t>
-            </a:r>
-            <a:br/>
-            <a:r>
-              <a:t>    ┓ All Hooks (5 total)             ✓ Active</a:t>
-            </a:r>
-            <a:br/>
-            <a:r>
-              <a:t>    ┓ DocumentProcessingTool          ✓ Active</a:t>
+              <a:defRPr sz="1200">
+                <a:solidFill>
+                  <a:srgbClr val="404040"/>
+                </a:solidFill>
+              </a:defRPr>
+            </a:pPr>
+            <a:r>
+              <a:t>Dashboard displays all submitted claims with real-time status, fraud scores, and compliance validation results. Users can track claim processing through multi-agent pipeline.</a:t>
             </a:r>
           </a:p>
         </p:txBody>
@@ -10743,28 +9869,52 @@
           <a:lstStyle/>
           <a:p>
             <a:pPr>
-              <a:defRPr sz="3200" b="1">
+              <a:defRPr sz="2800" b="1">
                 <a:solidFill>
                   <a:srgbClr val="FFFFFF"/>
                 </a:solidFill>
               </a:defRPr>
             </a:pPr>
             <a:r>
-              <a:t>Slide 26: Multi-Agent Interaction Pattern</a:t>
-            </a:r>
-          </a:p>
-        </p:txBody>
-      </p:sp>
-      <p:sp>
-        <p:nvSpPr>
-          <p:cNvPr id="4" name="TextBox 3"/>
+              <a:t>Slide 26: Step 3 - AI Assessment Results &amp; Decision</a:t>
+            </a:r>
+          </a:p>
+        </p:txBody>
+      </p:sp>
+      <p:pic>
+        <p:nvPicPr>
+          <p:cNvPr id="4" name="Picture 3" descr="screenshot_claim_detail.png"/>
+          <p:cNvPicPr>
+            <a:picLocks noChangeAspect="1"/>
+          </p:cNvPicPr>
+          <p:nvPr/>
+        </p:nvPicPr>
+        <p:blipFill>
+          <a:blip r:embed="rId2"/>
+          <a:stretch>
+            <a:fillRect/>
+          </a:stretch>
+        </p:blipFill>
+        <p:spPr>
+          <a:xfrm>
+            <a:off x="182880" y="822960"/>
+            <a:ext cx="8778240" cy="6583680"/>
+          </a:xfrm>
+          <a:prstGeom prst="rect">
+            <a:avLst/>
+          </a:prstGeom>
+        </p:spPr>
+      </p:pic>
+      <p:sp>
+        <p:nvSpPr>
+          <p:cNvPr id="5" name="TextBox 4"/>
           <p:cNvSpPr txBox="1"/>
           <p:nvPr/>
         </p:nvSpPr>
         <p:spPr>
           <a:xfrm>
-            <a:off x="457200" y="1005840"/>
-            <a:ext cx="8229600" cy="5486400"/>
+            <a:off x="457200" y="6217920"/>
+            <a:ext cx="8229600" cy="731520"/>
           </a:xfrm>
           <a:prstGeom prst="rect">
             <a:avLst/>
@@ -10778,133 +9928,14 @@
           <a:lstStyle/>
           <a:p>
             <a:pPr>
-              <a:spcBef>
-                <a:spcPts val="200"/>
-              </a:spcBef>
-              <a:spcAft>
-                <a:spcPts val="200"/>
-              </a:spcAft>
-              <a:defRPr sz="1100">
-                <a:solidFill>
-                  <a:srgbClr val="404040"/>
-                </a:solidFill>
-                <a:latin typeface="Courier New"/>
-              </a:defRPr>
-            </a:pPr>
-            <a:r>
-              <a:t>MULTI-AGENT INTERACTION PATTERN</a:t>
-            </a:r>
-            <a:br/>
-            <a:r>
-              <a:t>    </a:t>
-            </a:r>
-            <a:br/>
-            <a:r>
-              <a:t>    ① INPUT LAYER</a:t>
-            </a:r>
-            <a:br/>
-            <a:r>
-              <a:t>       ↓</a:t>
-            </a:r>
-            <a:br/>
-            <a:r>
-              <a:t>    ② CUSTOMER AGENT (Validates customer &amp; extracts claim data)</a:t>
-            </a:r>
-            <a:br/>
-            <a:r>
-              <a:t>       ↓</a:t>
-            </a:r>
-            <a:br/>
-            <a:r>
-              <a:t>    ③ KNOWLEDGE AGENT (Retrieves regulatory knowledge via MCP)</a:t>
-            </a:r>
-            <a:br/>
-            <a:r>
-              <a:t>       ↓</a:t>
-            </a:r>
-            <a:br/>
-            <a:r>
-              <a:t>    ④ PARALLEL EXECUTION:</a:t>
-            </a:r>
-            <a:br/>
-            <a:r>
-              <a:t>       ├─ COMPLIANCE AGENT (IRDAI/SOX/AML validation)</a:t>
-            </a:r>
-            <a:br/>
-            <a:r>
-              <a:t>       └─ RISK AGENT (Fraud detection &amp; anomaly scoring)</a:t>
-            </a:r>
-            <a:br/>
-            <a:r>
-              <a:t>       ↓</a:t>
-            </a:r>
-            <a:br/>
-            <a:r>
-              <a:t>    ⑤ DECISION AGENT (Synthesizes results → Final recommendation)</a:t>
-            </a:r>
-            <a:br/>
-            <a:r>
-              <a:t>       ├─ Approval with confidence score</a:t>
-            </a:r>
-            <a:br/>
-            <a:r>
-              <a:t>       ├─ Rejection with reasoning</a:t>
-            </a:r>
-            <a:br/>
-            <a:r>
-              <a:t>       └─ Pending Review with required actions</a:t>
-            </a:r>
-            <a:br/>
-            <a:r>
-              <a:t>       ↓</a:t>
-            </a:r>
-            <a:br/>
-            <a:r>
-              <a:t>    ⑥ AUDIT AGENT (Creates immutable record)</a:t>
-            </a:r>
-            <a:br/>
-            <a:r>
-              <a:t>       └─ Hash-chained audit log</a:t>
-            </a:r>
-            <a:br/>
-            <a:r>
-              <a:t>       └─ Decision reasoning</a:t>
-            </a:r>
-            <a:br/>
-            <a:r>
-              <a:t>       └─ Compliance validation results</a:t>
-            </a:r>
-            <a:br/>
-            <a:r>
-              <a:t>       ↓</a:t>
-            </a:r>
-            <a:br/>
-            <a:r>
-              <a:t>    ⑦ OUTPUT LAYER</a:t>
-            </a:r>
-            <a:br/>
-            <a:r>
-              <a:t>       ├─ Assessment result (Decision + Confidence)</a:t>
-            </a:r>
-            <a:br/>
-            <a:r>
-              <a:t>       ├─ Audit trail (Complete history)</a:t>
-            </a:r>
-            <a:br/>
-            <a:r>
-              <a:t>       └─ Explainable reasoning (Why decision made)</a:t>
-            </a:r>
-            <a:br/>
-            <a:r>
-              <a:t>    </a:t>
-            </a:r>
-            <a:br/>
-            <a:r>
-              <a:t>    Each agent communicates via AgentResult dataclass:</a:t>
-            </a:r>
-            <a:br/>
-            <a:r>
-              <a:t>    • agent_name, success, data, reasoning, confidence, duration_ms, error</a:t>
+              <a:defRPr sz="1200">
+                <a:solidFill>
+                  <a:srgbClr val="404040"/>
+                </a:solidFill>
+              </a:defRPr>
+            </a:pPr>
+            <a:r>
+              <a:t>Detailed assessment results show AI agent outputs: fraud scores, compliance validation (IRDAI/SOX/AML), risk scoring, final recommendation with confidence, and complete audit trail.</a:t>
             </a:r>
           </a:p>
         </p:txBody>
@@ -10997,34 +10028,58 @@
           <a:noFill/>
         </p:spPr>
         <p:txBody>
-          <a:bodyPr wrap="square">
+          <a:bodyPr wrap="none">
             <a:spAutoFit/>
           </a:bodyPr>
           <a:lstStyle/>
           <a:p>
             <a:pPr>
-              <a:defRPr sz="3200" b="1">
+              <a:defRPr sz="2800" b="1">
                 <a:solidFill>
                   <a:srgbClr val="FFFFFF"/>
                 </a:solidFill>
               </a:defRPr>
             </a:pPr>
             <a:r>
-              <a:t>Slide 27: Assessment Results Sample</a:t>
-            </a:r>
-          </a:p>
-        </p:txBody>
-      </p:sp>
-      <p:sp>
-        <p:nvSpPr>
-          <p:cNvPr id="4" name="TextBox 3"/>
+              <a:t>Slide 27: REST API Documentation &amp; Integration</a:t>
+            </a:r>
+          </a:p>
+        </p:txBody>
+      </p:sp>
+      <p:pic>
+        <p:nvPicPr>
+          <p:cNvPr id="4" name="Picture 3" descr="screenshot_api_docs.png"/>
+          <p:cNvPicPr>
+            <a:picLocks noChangeAspect="1"/>
+          </p:cNvPicPr>
+          <p:nvPr/>
+        </p:nvPicPr>
+        <p:blipFill>
+          <a:blip r:embed="rId2"/>
+          <a:stretch>
+            <a:fillRect/>
+          </a:stretch>
+        </p:blipFill>
+        <p:spPr>
+          <a:xfrm>
+            <a:off x="182880" y="822960"/>
+            <a:ext cx="8778240" cy="6583680"/>
+          </a:xfrm>
+          <a:prstGeom prst="rect">
+            <a:avLst/>
+          </a:prstGeom>
+        </p:spPr>
+      </p:pic>
+      <p:sp>
+        <p:nvSpPr>
+          <p:cNvPr id="5" name="TextBox 4"/>
           <p:cNvSpPr txBox="1"/>
           <p:nvPr/>
         </p:nvSpPr>
         <p:spPr>
           <a:xfrm>
-            <a:off x="640080" y="1097280"/>
-            <a:ext cx="7863840" cy="5303520"/>
+            <a:off x="457200" y="6217920"/>
+            <a:ext cx="8229600" cy="731520"/>
           </a:xfrm>
           <a:prstGeom prst="rect">
             <a:avLst/>
@@ -11036,383 +10091,16 @@
             <a:spAutoFit/>
           </a:bodyPr>
           <a:lstStyle/>
-          <a:p/>
-          <a:p>
-            <a:pPr lvl="1">
-              <a:spcBef>
-                <a:spcPts val="400"/>
-              </a:spcBef>
-              <a:spcAft>
-                <a:spcPts val="400"/>
-              </a:spcAft>
-              <a:defRPr sz="1400">
-                <a:solidFill>
-                  <a:srgbClr val="404040"/>
-                </a:solidFill>
-              </a:defRPr>
-            </a:pPr>
-            <a:r>
-              <a:t>Example Assessment Output (from Dashboard):</a:t>
-            </a:r>
-          </a:p>
-          <a:p>
-            <a:pPr lvl="1">
-              <a:spcBef>
-                <a:spcPts val="400"/>
-              </a:spcBef>
-              <a:spcAft>
-                <a:spcPts val="400"/>
-              </a:spcAft>
-              <a:defRPr sz="1400">
-                <a:solidFill>
-                  <a:srgbClr val="404040"/>
-                </a:solidFill>
-              </a:defRPr>
-            </a:pPr>
-            <a:r>
-              <a:t>┌─────────────────────────────────────────────────────────┐</a:t>
-            </a:r>
-          </a:p>
-          <a:p>
-            <a:pPr lvl="1">
-              <a:spcBef>
-                <a:spcPts val="400"/>
-              </a:spcBef>
-              <a:spcAft>
-                <a:spcPts val="400"/>
-              </a:spcAft>
-              <a:defRPr sz="1400">
-                <a:solidFill>
-                  <a:srgbClr val="404040"/>
-                </a:solidFill>
-              </a:defRPr>
-            </a:pPr>
-            <a:r>
-              <a:t>│ CLAIM: CLM-20260614-9FB40756                            │</a:t>
-            </a:r>
-          </a:p>
-          <a:p>
-            <a:pPr lvl="1">
-              <a:spcBef>
-                <a:spcPts val="400"/>
-              </a:spcBef>
-              <a:spcAft>
-                <a:spcPts val="400"/>
-              </a:spcAft>
-              <a:defRPr sz="1400">
-                <a:solidFill>
-                  <a:srgbClr val="404040"/>
-                </a:solidFill>
-              </a:defRPr>
-            </a:pPr>
-            <a:r>
-              <a:t>│ Customer: Robert Williams | Type: Auto | Amount: $8,500 │</a:t>
-            </a:r>
-          </a:p>
-          <a:p>
-            <a:pPr lvl="1">
-              <a:spcBef>
-                <a:spcPts val="400"/>
-              </a:spcBef>
-              <a:spcAft>
-                <a:spcPts val="400"/>
-              </a:spcAft>
-              <a:defRPr sz="1400">
-                <a:solidFill>
-                  <a:srgbClr val="404040"/>
-                </a:solidFill>
-              </a:defRPr>
-            </a:pPr>
-            <a:r>
-              <a:t>└─────────────────────────────────────────────────────────┘</a:t>
-            </a:r>
-          </a:p>
-          <a:p>
-            <a:pPr lvl="1">
-              <a:spcBef>
-                <a:spcPts val="400"/>
-              </a:spcBef>
-              <a:spcAft>
-                <a:spcPts val="400"/>
-              </a:spcAft>
-              <a:defRPr sz="1400">
-                <a:solidFill>
-                  <a:srgbClr val="404040"/>
-                </a:solidFill>
-              </a:defRPr>
-            </a:pPr>
-            <a:r>
-              <a:t>📊 ASSESSMENT SCORES:</a:t>
-            </a:r>
-          </a:p>
-          <a:p>
-            <a:pPr lvl="1">
-              <a:spcBef>
-                <a:spcPts val="400"/>
-              </a:spcBef>
-              <a:spcAft>
-                <a:spcPts val="400"/>
-              </a:spcAft>
-              <a:defRPr sz="1400">
-                <a:solidFill>
-                  <a:srgbClr val="404040"/>
-                </a:solidFill>
-              </a:defRPr>
-            </a:pPr>
-            <a:r>
-              <a:t>Final Score: 0.842 ✓ (UNDER REVIEW - Agent synthesis)</a:t>
-            </a:r>
-          </a:p>
-          <a:p>
-            <a:pPr lvl="1">
-              <a:spcBef>
-                <a:spcPts val="400"/>
-              </a:spcBef>
-              <a:spcAft>
-                <a:spcPts val="400"/>
-              </a:spcAft>
-              <a:defRPr sz="1400">
-                <a:solidFill>
-                  <a:srgbClr val="404040"/>
-                </a:solidFill>
-              </a:defRPr>
-            </a:pPr>
-            <a:r>
-              <a:t>Compliance Score: 0.740 ✓ (Passed IRDAI/SOX/AML)</a:t>
-            </a:r>
-          </a:p>
-          <a:p>
-            <a:pPr lvl="1">
-              <a:spcBef>
-                <a:spcPts val="400"/>
-              </a:spcBef>
-              <a:spcAft>
-                <a:spcPts val="400"/>
-              </a:spcAft>
-              <a:defRPr sz="1400">
-                <a:solidFill>
-                  <a:srgbClr val="404040"/>
-                </a:solidFill>
-              </a:defRPr>
-            </a:pPr>
-            <a:r>
-              <a:t>Fraud Score: 0.000 ✓ (No fraud indicators)</a:t>
-            </a:r>
-          </a:p>
-          <a:p>
-            <a:pPr lvl="1">
-              <a:spcBef>
-                <a:spcPts val="400"/>
-              </a:spcBef>
-              <a:spcAft>
-                <a:spcPts val="400"/>
-              </a:spcAft>
-              <a:defRPr sz="1400">
-                <a:solidFill>
-                  <a:srgbClr val="404040"/>
-                </a:solidFill>
-              </a:defRPr>
-            </a:pPr>
-            <a:r>
-              <a:t>Risk Score: 0.000 ✓ (Low risk profile)</a:t>
-            </a:r>
-          </a:p>
-          <a:p>
-            <a:pPr lvl="1">
-              <a:spcBef>
-                <a:spcPts val="400"/>
-              </a:spcBef>
-              <a:spcAft>
-                <a:spcPts val="400"/>
-              </a:spcAft>
-              <a:defRPr sz="1400">
-                <a:solidFill>
-                  <a:srgbClr val="404040"/>
-                </a:solidFill>
-              </a:defRPr>
-            </a:pPr>
-            <a:r>
-              <a:t>Identity Confidence: 0.500 ✓ (Verified)</a:t>
-            </a:r>
-          </a:p>
-          <a:p>
-            <a:pPr lvl="1">
-              <a:spcBef>
-                <a:spcPts val="400"/>
-              </a:spcBef>
-              <a:spcAft>
-                <a:spcPts val="400"/>
-              </a:spcAft>
-              <a:defRPr sz="1400">
-                <a:solidFill>
-                  <a:srgbClr val="404040"/>
-                </a:solidFill>
-              </a:defRPr>
-            </a:pPr>
-            <a:r>
-              <a:t>✅ COMPLIANCE STATUS: PASS</a:t>
-            </a:r>
-          </a:p>
-          <a:p>
-            <a:pPr lvl="1">
-              <a:spcBef>
-                <a:spcPts val="400"/>
-              </a:spcBef>
-              <a:spcAft>
-                <a:spcPts val="400"/>
-              </a:spcAft>
-              <a:defRPr sz="1400">
-                <a:solidFill>
-                  <a:srgbClr val="404040"/>
-                </a:solidFill>
-              </a:defRPr>
-            </a:pPr>
-            <a:r>
-              <a:t>✓ IRDAI Validation: PASS</a:t>
-            </a:r>
-          </a:p>
-          <a:p>
-            <a:pPr lvl="1">
-              <a:spcBef>
-                <a:spcPts val="400"/>
-              </a:spcBef>
-              <a:spcAft>
-                <a:spcPts val="400"/>
-              </a:spcAft>
-              <a:defRPr sz="1400">
-                <a:solidFill>
-                  <a:srgbClr val="404040"/>
-                </a:solidFill>
-              </a:defRPr>
-            </a:pPr>
-            <a:r>
-              <a:t>✓ SOX Compliance: PASS</a:t>
-            </a:r>
-          </a:p>
-          <a:p>
-            <a:pPr lvl="1">
-              <a:spcBef>
-                <a:spcPts val="400"/>
-              </a:spcBef>
-              <a:spcAft>
-                <a:spcPts val="400"/>
-              </a:spcAft>
-              <a:defRPr sz="1400">
-                <a:solidFill>
-                  <a:srgbClr val="404040"/>
-                </a:solidFill>
-              </a:defRPr>
-            </a:pPr>
-            <a:r>
-              <a:t>✓ AML/KYC: PASS</a:t>
-            </a:r>
-          </a:p>
-          <a:p>
-            <a:pPr lvl="1">
-              <a:spcBef>
-                <a:spcPts val="400"/>
-              </a:spcBef>
-              <a:spcAft>
-                <a:spcPts val="400"/>
-              </a:spcAft>
-              <a:defRPr sz="1400">
-                <a:solidFill>
-                  <a:srgbClr val="404040"/>
-                </a:solidFill>
-              </a:defRPr>
-            </a:pPr>
-            <a:r>
-              <a:t>✓ Coverage Validation: PASS</a:t>
-            </a:r>
-          </a:p>
-          <a:p>
-            <a:pPr lvl="1">
-              <a:spcBef>
-                <a:spcPts val="400"/>
-              </a:spcBef>
-              <a:spcAft>
-                <a:spcPts val="400"/>
-              </a:spcAft>
-              <a:defRPr sz="1400">
-                <a:solidFill>
-                  <a:srgbClr val="404040"/>
-                </a:solidFill>
-              </a:defRPr>
-            </a:pPr>
-            <a:r>
-              <a:t>⏱️ PROCESSING TIMELINE:</a:t>
-            </a:r>
-          </a:p>
-          <a:p>
-            <a:pPr lvl="1">
-              <a:spcBef>
-                <a:spcPts val="400"/>
-              </a:spcBef>
-              <a:spcAft>
-                <a:spcPts val="400"/>
-              </a:spcAft>
-              <a:defRPr sz="1400">
-                <a:solidFill>
-                  <a:srgbClr val="404040"/>
-                </a:solidFill>
-              </a:defRPr>
-            </a:pPr>
-            <a:r>
-              <a:t>Submitted: 6/14/2026, 7:05:46 AM</a:t>
-            </a:r>
-          </a:p>
-          <a:p>
-            <a:pPr lvl="1">
-              <a:spcBef>
-                <a:spcPts val="400"/>
-              </a:spcBef>
-              <a:spcAft>
-                <a:spcPts val="400"/>
-              </a:spcAft>
-              <a:defRPr sz="1400">
-                <a:solidFill>
-                  <a:srgbClr val="404040"/>
-                </a:solidFill>
-              </a:defRPr>
-            </a:pPr>
-            <a:r>
-              <a:t>Assessed: 6/14/2026, 7:09:24 AM</a:t>
-            </a:r>
-          </a:p>
-          <a:p>
-            <a:pPr lvl="1">
-              <a:spcBef>
-                <a:spcPts val="400"/>
-              </a:spcBef>
-              <a:spcAft>
-                <a:spcPts val="400"/>
-              </a:spcAft>
-              <a:defRPr sz="1400">
-                <a:solidFill>
-                  <a:srgbClr val="404040"/>
-                </a:solidFill>
-              </a:defRPr>
-            </a:pPr>
-            <a:r>
-              <a:t>Duration: ~3.5 minutes (agents + hooks)</a:t>
-            </a:r>
-          </a:p>
-          <a:p>
-            <a:pPr lvl="1">
-              <a:spcBef>
-                <a:spcPts val="400"/>
-              </a:spcBef>
-              <a:spcAft>
-                <a:spcPts val="400"/>
-              </a:spcAft>
-              <a:defRPr sz="1400">
-                <a:solidFill>
-                  <a:srgbClr val="404040"/>
-                </a:solidFill>
-              </a:defRPr>
-            </a:pPr>
-            <a:r>
-              <a:t>Status: UNDER REVIEW → Ready for manual verification (optional)</a:t>
+          <a:p>
+            <a:pPr>
+              <a:defRPr sz="1200">
+                <a:solidFill>
+                  <a:srgbClr val="404040"/>
+                </a:solidFill>
+              </a:defRPr>
+            </a:pPr>
+            <a:r>
+              <a:t>Swagger UI provides interactive API documentation. Endpoints support claim submission, status retrieval, assessment triggering, audit trail access, and dashboard metrics.</a:t>
             </a:r>
           </a:p>
         </p:txBody>
@@ -11426,137 +10114,6 @@
 </file>
 
 <file path=ppt/slides/slide28.xml><?xml version="1.0" encoding="utf-8"?>
-<p:sld xmlns:a="http://schemas.openxmlformats.org/drawingml/2006/main" xmlns:p="http://schemas.openxmlformats.org/presentationml/2006/main" xmlns:r="http://schemas.openxmlformats.org/officeDocument/2006/relationships">
-  <p:cSld>
-    <p:bg>
-      <p:bgPr>
-        <a:solidFill>
-          <a:srgbClr val="19376D"/>
-        </a:solidFill>
-        <a:effectLst/>
-      </p:bgPr>
-    </p:bg>
-    <p:spTree>
-      <p:nvGrpSpPr>
-        <p:cNvPr id="1" name=""/>
-        <p:cNvGrpSpPr/>
-        <p:nvPr/>
-      </p:nvGrpSpPr>
-      <p:grpSpPr/>
-      <p:sp>
-        <p:nvSpPr>
-          <p:cNvPr id="2" name="TextBox 1"/>
-          <p:cNvSpPr txBox="1"/>
-          <p:nvPr/>
-        </p:nvSpPr>
-        <p:spPr>
-          <a:xfrm>
-            <a:off x="457200" y="2286000"/>
-            <a:ext cx="8229600" cy="1371600"/>
-          </a:xfrm>
-          <a:prstGeom prst="rect">
-            <a:avLst/>
-          </a:prstGeom>
-          <a:noFill/>
-        </p:spPr>
-        <p:txBody>
-          <a:bodyPr wrap="square">
-            <a:spAutoFit/>
-          </a:bodyPr>
-          <a:lstStyle/>
-          <a:p>
-            <a:pPr algn="ctr">
-              <a:defRPr sz="5400" b="1">
-                <a:solidFill>
-                  <a:srgbClr val="FF7F27"/>
-                </a:solidFill>
-              </a:defRPr>
-            </a:pPr>
-            <a:r>
-              <a:t>Ready for Production Deployment</a:t>
-            </a:r>
-          </a:p>
-        </p:txBody>
-      </p:sp>
-      <p:sp>
-        <p:nvSpPr>
-          <p:cNvPr id="3" name="TextBox 2"/>
-          <p:cNvSpPr txBox="1"/>
-          <p:nvPr/>
-        </p:nvSpPr>
-        <p:spPr>
-          <a:xfrm>
-            <a:off x="457200" y="3840480"/>
-            <a:ext cx="8229600" cy="914400"/>
-          </a:xfrm>
-          <a:prstGeom prst="rect">
-            <a:avLst/>
-          </a:prstGeom>
-          <a:noFill/>
-        </p:spPr>
-        <p:txBody>
-          <a:bodyPr wrap="square">
-            <a:spAutoFit/>
-          </a:bodyPr>
-          <a:lstStyle/>
-          <a:p>
-            <a:pPr algn="ctr">
-              <a:defRPr sz="2800">
-                <a:solidFill>
-                  <a:srgbClr val="FFFFFF"/>
-                </a:solidFill>
-              </a:defRPr>
-            </a:pPr>
-            <a:r>
-              <a:t>Autonomous Insurance Claim Assessment System</a:t>
-            </a:r>
-          </a:p>
-        </p:txBody>
-      </p:sp>
-      <p:sp>
-        <p:nvSpPr>
-          <p:cNvPr id="4" name="TextBox 3"/>
-          <p:cNvSpPr txBox="1"/>
-          <p:nvPr/>
-        </p:nvSpPr>
-        <p:spPr>
-          <a:xfrm>
-            <a:off x="457200" y="5943600"/>
-            <a:ext cx="8229600" cy="731520"/>
-          </a:xfrm>
-          <a:prstGeom prst="rect">
-            <a:avLst/>
-          </a:prstGeom>
-          <a:noFill/>
-        </p:spPr>
-        <p:txBody>
-          <a:bodyPr wrap="square">
-            <a:spAutoFit/>
-          </a:bodyPr>
-          <a:lstStyle/>
-          <a:p>
-            <a:pPr algn="ctr">
-              <a:defRPr sz="1800">
-                <a:solidFill>
-                  <a:srgbClr val="3B5998"/>
-                </a:solidFill>
-              </a:defRPr>
-            </a:pPr>
-            <a:r>
-              <a:t>Contact for Enterprise License &amp; Implementation</a:t>
-            </a:r>
-          </a:p>
-        </p:txBody>
-      </p:sp>
-    </p:spTree>
-  </p:cSld>
-  <p:clrMapOvr>
-    <a:masterClrMapping/>
-  </p:clrMapOvr>
-</p:sld>
-</file>
-
-<file path=ppt/slides/slide3.xml><?xml version="1.0" encoding="utf-8"?>
 <p:sld xmlns:a="http://schemas.openxmlformats.org/drawingml/2006/main" xmlns:p="http://schemas.openxmlformats.org/presentationml/2006/main" xmlns:r="http://schemas.openxmlformats.org/officeDocument/2006/relationships">
   <p:cSld>
     <p:bg>
@@ -11649,7 +10206,7 @@
               </a:defRPr>
             </a:pPr>
             <a:r>
-              <a:t>Slide 3: Solution Overview</a:t>
+              <a:t>Slide 28: Complete Claim Assessment Workflow</a:t>
             </a:r>
           </a:p>
         </p:txBody>
@@ -11677,201 +10234,291 @@
           <a:lstStyle/>
           <a:p/>
           <a:p>
-            <a:pPr>
-              <a:spcBef>
-                <a:spcPts val="400"/>
-              </a:spcBef>
-              <a:spcAft>
-                <a:spcPts val="400"/>
-              </a:spcAft>
-              <a:defRPr sz="1400">
-                <a:solidFill>
-                  <a:srgbClr val="404040"/>
-                </a:solidFill>
-              </a:defRPr>
-            </a:pPr>
-            <a:r>
-              <a:t>✓ Autonomous AI Assessment Pipeline</a:t>
-            </a:r>
-          </a:p>
-          <a:p>
-            <a:pPr lvl="1">
-              <a:spcBef>
-                <a:spcPts val="400"/>
-              </a:spcBef>
-              <a:spcAft>
-                <a:spcPts val="400"/>
-              </a:spcAft>
-              <a:defRPr sz="1400">
-                <a:solidFill>
-                  <a:srgbClr val="404040"/>
-                </a:solidFill>
-              </a:defRPr>
-            </a:pPr>
-            <a:r>
-              <a:t>- End-to-end claim processing without human intervention</a:t>
-            </a:r>
-          </a:p>
-          <a:p>
-            <a:pPr lvl="1">
-              <a:spcBef>
-                <a:spcPts val="400"/>
-              </a:spcBef>
-              <a:spcAft>
-                <a:spcPts val="400"/>
-              </a:spcAft>
-              <a:defRPr sz="1400">
-                <a:solidFill>
-                  <a:srgbClr val="404040"/>
-                </a:solidFill>
-              </a:defRPr>
-            </a:pPr>
-            <a:r>
-              <a:t>✓ Multi-Agent Architecture</a:t>
-            </a:r>
-          </a:p>
-          <a:p>
-            <a:pPr lvl="1">
-              <a:spcBef>
-                <a:spcPts val="400"/>
-              </a:spcBef>
-              <a:spcAft>
-                <a:spcPts val="400"/>
-              </a:spcAft>
-              <a:defRPr sz="1400">
-                <a:solidFill>
-                  <a:srgbClr val="404040"/>
-                </a:solidFill>
-              </a:defRPr>
-            </a:pPr>
-            <a:r>
-              <a:t>- 6 specialized agents for different claim assessment aspects</a:t>
-            </a:r>
-          </a:p>
-          <a:p>
-            <a:pPr lvl="1">
-              <a:spcBef>
-                <a:spcPts val="400"/>
-              </a:spcBef>
-              <a:spcAft>
-                <a:spcPts val="400"/>
-              </a:spcAft>
-              <a:defRPr sz="1400">
-                <a:solidFill>
-                  <a:srgbClr val="404040"/>
-                </a:solidFill>
-              </a:defRPr>
-            </a:pPr>
-            <a:r>
-              <a:t>- Fraud detection, compliance validation, risk scoring</a:t>
-            </a:r>
-          </a:p>
-          <a:p>
-            <a:pPr lvl="1">
-              <a:spcBef>
-                <a:spcPts val="400"/>
-              </a:spcBef>
-              <a:spcAft>
-                <a:spcPts val="400"/>
-              </a:spcAft>
-              <a:defRPr sz="1400">
-                <a:solidFill>
-                  <a:srgbClr val="404040"/>
-                </a:solidFill>
-              </a:defRPr>
-            </a:pPr>
-            <a:r>
-              <a:t>✓ Full Regulatory Compliance</a:t>
-            </a:r>
-          </a:p>
-          <a:p>
-            <a:pPr lvl="1">
-              <a:spcBef>
-                <a:spcPts val="400"/>
-              </a:spcBef>
-              <a:spcAft>
-                <a:spcPts val="400"/>
-              </a:spcAft>
-              <a:defRPr sz="1400">
-                <a:solidFill>
-                  <a:srgbClr val="404040"/>
-                </a:solidFill>
-              </a:defRPr>
-            </a:pPr>
-            <a:r>
-              <a:t>- IRDAI, SOX, AML regulation enforcement</a:t>
-            </a:r>
-          </a:p>
-          <a:p>
-            <a:pPr lvl="1">
-              <a:spcBef>
-                <a:spcPts val="400"/>
-              </a:spcBef>
-              <a:spcAft>
-                <a:spcPts val="400"/>
-              </a:spcAft>
-              <a:defRPr sz="1400">
-                <a:solidFill>
-                  <a:srgbClr val="404040"/>
-                </a:solidFill>
-              </a:defRPr>
-            </a:pPr>
-            <a:r>
-              <a:t>- Immutable audit trails for all decisions</a:t>
-            </a:r>
-          </a:p>
-          <a:p>
-            <a:pPr lvl="1">
-              <a:spcBef>
-                <a:spcPts val="400"/>
-              </a:spcBef>
-              <a:spcAft>
-                <a:spcPts val="400"/>
-              </a:spcAft>
-              <a:defRPr sz="1400">
-                <a:solidFill>
-                  <a:srgbClr val="404040"/>
-                </a:solidFill>
-              </a:defRPr>
-            </a:pPr>
-            <a:r>
-              <a:t>✓ Complete Traceability</a:t>
-            </a:r>
-          </a:p>
-          <a:p>
-            <a:pPr lvl="1">
-              <a:spcBef>
-                <a:spcPts val="400"/>
-              </a:spcBef>
-              <a:spcAft>
-                <a:spcPts val="400"/>
-              </a:spcAft>
-              <a:defRPr sz="1400">
-                <a:solidFill>
-                  <a:srgbClr val="404040"/>
-                </a:solidFill>
-              </a:defRPr>
-            </a:pPr>
-            <a:r>
-              <a:t>- Chain-of-thought reasoning for every decision</a:t>
-            </a:r>
-          </a:p>
-          <a:p>
-            <a:pPr lvl="1">
-              <a:spcBef>
-                <a:spcPts val="400"/>
-              </a:spcBef>
-              <a:spcAft>
-                <a:spcPts val="400"/>
-              </a:spcAft>
-              <a:defRPr sz="1400">
-                <a:solidFill>
-                  <a:srgbClr val="404040"/>
-                </a:solidFill>
-              </a:defRPr>
-            </a:pPr>
-            <a:r>
-              <a:t>- Explainable AI with confidence scores</a:t>
+            <a:pPr lvl="1">
+              <a:spcBef>
+                <a:spcPts val="400"/>
+              </a:spcBef>
+              <a:spcAft>
+                <a:spcPts val="400"/>
+              </a:spcAft>
+              <a:defRPr sz="1400">
+                <a:solidFill>
+                  <a:srgbClr val="404040"/>
+                </a:solidFill>
+              </a:defRPr>
+            </a:pPr>
+            <a:r>
+              <a:t>End-to-End Automated Process:</a:t>
+            </a:r>
+          </a:p>
+          <a:p>
+            <a:pPr lvl="1">
+              <a:spcBef>
+                <a:spcPts val="400"/>
+              </a:spcBef>
+              <a:spcAft>
+                <a:spcPts val="400"/>
+              </a:spcAft>
+              <a:defRPr sz="1400">
+                <a:solidFill>
+                  <a:srgbClr val="404040"/>
+                </a:solidFill>
+              </a:defRPr>
+            </a:pPr>
+            <a:r>
+              <a:t>1️⃣  SUBMISSION: User fills form → System validates → Stores in database</a:t>
+            </a:r>
+          </a:p>
+          <a:p>
+            <a:pPr lvl="1">
+              <a:spcBef>
+                <a:spcPts val="400"/>
+              </a:spcBef>
+              <a:spcAft>
+                <a:spcPts val="400"/>
+              </a:spcAft>
+              <a:defRPr sz="1400">
+                <a:solidFill>
+                  <a:srgbClr val="404040"/>
+                </a:solidFill>
+              </a:defRPr>
+            </a:pPr>
+            <a:r>
+              <a:t>2️⃣  PIPELINE PROCESSING (Automated by 6 AI Agents):</a:t>
+            </a:r>
+          </a:p>
+          <a:p>
+            <a:pPr lvl="1">
+              <a:spcBef>
+                <a:spcPts val="400"/>
+              </a:spcBef>
+              <a:spcAft>
+                <a:spcPts val="400"/>
+              </a:spcAft>
+              <a:defRPr sz="1400">
+                <a:solidFill>
+                  <a:srgbClr val="404040"/>
+                </a:solidFill>
+              </a:defRPr>
+            </a:pPr>
+            <a:r>
+              <a:t>InputValidationHook → SecurityHook → CustomerAgent → KnowledgeAgent (MCP)</a:t>
+            </a:r>
+          </a:p>
+          <a:p>
+            <a:pPr lvl="1">
+              <a:spcBef>
+                <a:spcPts val="400"/>
+              </a:spcBef>
+              <a:spcAft>
+                <a:spcPts val="400"/>
+              </a:spcAft>
+              <a:defRPr sz="1400">
+                <a:solidFill>
+                  <a:srgbClr val="404040"/>
+                </a:solidFill>
+              </a:defRPr>
+            </a:pPr>
+            <a:r>
+              <a:t>→ ComplianceAgent ⟷ RiskAgent (parallel) → DecisionAgent → AuditAgent</a:t>
+            </a:r>
+          </a:p>
+          <a:p>
+            <a:pPr lvl="1">
+              <a:spcBef>
+                <a:spcPts val="400"/>
+              </a:spcBef>
+              <a:spcAft>
+                <a:spcPts val="400"/>
+              </a:spcAft>
+              <a:defRPr sz="1400">
+                <a:solidFill>
+                  <a:srgbClr val="404040"/>
+                </a:solidFill>
+              </a:defRPr>
+            </a:pPr>
+            <a:r>
+              <a:t>→ OutputValidationHook</a:t>
+            </a:r>
+          </a:p>
+          <a:p>
+            <a:pPr lvl="1">
+              <a:spcBef>
+                <a:spcPts val="400"/>
+              </a:spcBef>
+              <a:spcAft>
+                <a:spcPts val="400"/>
+              </a:spcAft>
+              <a:defRPr sz="1400">
+                <a:solidFill>
+                  <a:srgbClr val="404040"/>
+                </a:solidFill>
+              </a:defRPr>
+            </a:pPr>
+            <a:r>
+              <a:t>3️⃣  RESULTS DISPLAY:</a:t>
+            </a:r>
+          </a:p>
+          <a:p>
+            <a:pPr lvl="1">
+              <a:spcBef>
+                <a:spcPts val="400"/>
+              </a:spcBef>
+              <a:spcAft>
+                <a:spcPts val="400"/>
+              </a:spcAft>
+              <a:defRPr sz="1400">
+                <a:solidFill>
+                  <a:srgbClr val="404040"/>
+                </a:solidFill>
+              </a:defRPr>
+            </a:pPr>
+            <a:r>
+              <a:t>Assessment scores (Final, Compliance, Fraud, Risk, Identity)</a:t>
+            </a:r>
+          </a:p>
+          <a:p>
+            <a:pPr lvl="1">
+              <a:spcBef>
+                <a:spcPts val="400"/>
+              </a:spcBef>
+              <a:spcAft>
+                <a:spcPts val="400"/>
+              </a:spcAft>
+              <a:defRPr sz="1400">
+                <a:solidFill>
+                  <a:srgbClr val="404040"/>
+                </a:solidFill>
+              </a:defRPr>
+            </a:pPr>
+            <a:r>
+              <a:t>Compliance status (IRDAI ✓ SOX ✓ AML ✓ KYC ✓)</a:t>
+            </a:r>
+          </a:p>
+          <a:p>
+            <a:pPr lvl="1">
+              <a:spcBef>
+                <a:spcPts val="400"/>
+              </a:spcBef>
+              <a:spcAft>
+                <a:spcPts val="400"/>
+              </a:spcAft>
+              <a:defRPr sz="1400">
+                <a:solidFill>
+                  <a:srgbClr val="404040"/>
+                </a:solidFill>
+              </a:defRPr>
+            </a:pPr>
+            <a:r>
+              <a:t>Fraud indicators and risk flags</a:t>
+            </a:r>
+          </a:p>
+          <a:p>
+            <a:pPr lvl="1">
+              <a:spcBef>
+                <a:spcPts val="400"/>
+              </a:spcBef>
+              <a:spcAft>
+                <a:spcPts val="400"/>
+              </a:spcAft>
+              <a:defRPr sz="1400">
+                <a:solidFill>
+                  <a:srgbClr val="404040"/>
+                </a:solidFill>
+              </a:defRPr>
+            </a:pPr>
+            <a:r>
+              <a:t>Complete audit trail with reasoning</a:t>
+            </a:r>
+          </a:p>
+          <a:p>
+            <a:pPr lvl="1">
+              <a:spcBef>
+                <a:spcPts val="400"/>
+              </a:spcBef>
+              <a:spcAft>
+                <a:spcPts val="400"/>
+              </a:spcAft>
+              <a:defRPr sz="1400">
+                <a:solidFill>
+                  <a:srgbClr val="404040"/>
+                </a:solidFill>
+              </a:defRPr>
+            </a:pPr>
+            <a:r>
+              <a:t>4️⃣  DECISION OUTPUT:</a:t>
+            </a:r>
+          </a:p>
+          <a:p>
+            <a:pPr lvl="1">
+              <a:spcBef>
+                <a:spcPts val="400"/>
+              </a:spcBef>
+              <a:spcAft>
+                <a:spcPts val="400"/>
+              </a:spcAft>
+              <a:defRPr sz="1400">
+                <a:solidFill>
+                  <a:srgbClr val="404040"/>
+                </a:solidFill>
+              </a:defRPr>
+            </a:pPr>
+            <a:r>
+              <a:t>Approval / Rejection / Pending Review</a:t>
+            </a:r>
+          </a:p>
+          <a:p>
+            <a:pPr lvl="1">
+              <a:spcBef>
+                <a:spcPts val="400"/>
+              </a:spcBef>
+              <a:spcAft>
+                <a:spcPts val="400"/>
+              </a:spcAft>
+              <a:defRPr sz="1400">
+                <a:solidFill>
+                  <a:srgbClr val="404040"/>
+                </a:solidFill>
+              </a:defRPr>
+            </a:pPr>
+            <a:r>
+              <a:t>Confidence score (0-100%)</a:t>
+            </a:r>
+          </a:p>
+          <a:p>
+            <a:pPr lvl="1">
+              <a:spcBef>
+                <a:spcPts val="400"/>
+              </a:spcBef>
+              <a:spcAft>
+                <a:spcPts val="400"/>
+              </a:spcAft>
+              <a:defRPr sz="1400">
+                <a:solidFill>
+                  <a:srgbClr val="404040"/>
+                </a:solidFill>
+              </a:defRPr>
+            </a:pPr>
+            <a:r>
+              <a:t>Explainable reasoning</a:t>
+            </a:r>
+          </a:p>
+          <a:p>
+            <a:pPr lvl="1">
+              <a:spcBef>
+                <a:spcPts val="400"/>
+              </a:spcBef>
+              <a:spcAft>
+                <a:spcPts val="400"/>
+              </a:spcAft>
+              <a:defRPr sz="1400">
+                <a:solidFill>
+                  <a:srgbClr val="404040"/>
+                </a:solidFill>
+              </a:defRPr>
+            </a:pPr>
+            <a:r>
+              <a:t>Audit trail for compliance</a:t>
             </a:r>
           </a:p>
         </p:txBody>
@@ -11884,7 +10531,138 @@
 </p:sld>
 </file>
 
-<file path=ppt/slides/slide4.xml><?xml version="1.0" encoding="utf-8"?>
+<file path=ppt/slides/slide29.xml><?xml version="1.0" encoding="utf-8"?>
+<p:sld xmlns:a="http://schemas.openxmlformats.org/drawingml/2006/main" xmlns:p="http://schemas.openxmlformats.org/presentationml/2006/main" xmlns:r="http://schemas.openxmlformats.org/officeDocument/2006/relationships">
+  <p:cSld>
+    <p:bg>
+      <p:bgPr>
+        <a:solidFill>
+          <a:srgbClr val="19376D"/>
+        </a:solidFill>
+        <a:effectLst/>
+      </p:bgPr>
+    </p:bg>
+    <p:spTree>
+      <p:nvGrpSpPr>
+        <p:cNvPr id="1" name=""/>
+        <p:cNvGrpSpPr/>
+        <p:nvPr/>
+      </p:nvGrpSpPr>
+      <p:grpSpPr/>
+      <p:sp>
+        <p:nvSpPr>
+          <p:cNvPr id="2" name="TextBox 1"/>
+          <p:cNvSpPr txBox="1"/>
+          <p:nvPr/>
+        </p:nvSpPr>
+        <p:spPr>
+          <a:xfrm>
+            <a:off x="457200" y="2286000"/>
+            <a:ext cx="8229600" cy="1371600"/>
+          </a:xfrm>
+          <a:prstGeom prst="rect">
+            <a:avLst/>
+          </a:prstGeom>
+          <a:noFill/>
+        </p:spPr>
+        <p:txBody>
+          <a:bodyPr wrap="square">
+            <a:spAutoFit/>
+          </a:bodyPr>
+          <a:lstStyle/>
+          <a:p>
+            <a:pPr algn="ctr">
+              <a:defRPr sz="5400" b="1">
+                <a:solidFill>
+                  <a:srgbClr val="FF7F27"/>
+                </a:solidFill>
+              </a:defRPr>
+            </a:pPr>
+            <a:r>
+              <a:t>Ready for Production Deployment</a:t>
+            </a:r>
+          </a:p>
+        </p:txBody>
+      </p:sp>
+      <p:sp>
+        <p:nvSpPr>
+          <p:cNvPr id="3" name="TextBox 2"/>
+          <p:cNvSpPr txBox="1"/>
+          <p:nvPr/>
+        </p:nvSpPr>
+        <p:spPr>
+          <a:xfrm>
+            <a:off x="457200" y="3840480"/>
+            <a:ext cx="8229600" cy="914400"/>
+          </a:xfrm>
+          <a:prstGeom prst="rect">
+            <a:avLst/>
+          </a:prstGeom>
+          <a:noFill/>
+        </p:spPr>
+        <p:txBody>
+          <a:bodyPr wrap="square">
+            <a:spAutoFit/>
+          </a:bodyPr>
+          <a:lstStyle/>
+          <a:p>
+            <a:pPr algn="ctr">
+              <a:defRPr sz="2800">
+                <a:solidFill>
+                  <a:srgbClr val="FFFFFF"/>
+                </a:solidFill>
+              </a:defRPr>
+            </a:pPr>
+            <a:r>
+              <a:t>Autonomous Insurance Claim Assessment System</a:t>
+            </a:r>
+          </a:p>
+        </p:txBody>
+      </p:sp>
+      <p:sp>
+        <p:nvSpPr>
+          <p:cNvPr id="4" name="TextBox 3"/>
+          <p:cNvSpPr txBox="1"/>
+          <p:nvPr/>
+        </p:nvSpPr>
+        <p:spPr>
+          <a:xfrm>
+            <a:off x="457200" y="5943600"/>
+            <a:ext cx="8229600" cy="731520"/>
+          </a:xfrm>
+          <a:prstGeom prst="rect">
+            <a:avLst/>
+          </a:prstGeom>
+          <a:noFill/>
+        </p:spPr>
+        <p:txBody>
+          <a:bodyPr wrap="square">
+            <a:spAutoFit/>
+          </a:bodyPr>
+          <a:lstStyle/>
+          <a:p>
+            <a:pPr algn="ctr">
+              <a:defRPr sz="1800">
+                <a:solidFill>
+                  <a:srgbClr val="3B5998"/>
+                </a:solidFill>
+              </a:defRPr>
+            </a:pPr>
+            <a:r>
+              <a:t>Contact for Enterprise License &amp; Implementation</a:t>
+            </a:r>
+          </a:p>
+        </p:txBody>
+      </p:sp>
+    </p:spTree>
+  </p:cSld>
+  <p:clrMapOvr>
+    <a:masterClrMapping/>
+  </p:clrMapOvr>
+</p:sld>
+</file>
+
+<file path=ppt/slides/slide3.xml><?xml version="1.0" encoding="utf-8"?>
 <p:sld xmlns:a="http://schemas.openxmlformats.org/drawingml/2006/main" xmlns:p="http://schemas.openxmlformats.org/presentationml/2006/main" xmlns:r="http://schemas.openxmlformats.org/officeDocument/2006/relationships">
   <p:cSld>
     <p:bg>
@@ -11977,7 +10755,7 @@
               </a:defRPr>
             </a:pPr>
             <a:r>
-              <a:t>Slide 4: Key Business Benefits</a:t>
+              <a:t>Slide 3: Solution Overview</a:t>
             </a:r>
           </a:p>
         </p:txBody>
@@ -12019,205 +10797,187 @@
               </a:defRPr>
             </a:pPr>
             <a:r>
-              <a:t>📈 Operational Impact</a:t>
-            </a:r>
-          </a:p>
-          <a:p>
-            <a:pPr lvl="1">
-              <a:spcBef>
-                <a:spcPts val="400"/>
-              </a:spcBef>
-              <a:spcAft>
-                <a:spcPts val="400"/>
-              </a:spcAft>
-              <a:defRPr sz="1400">
-                <a:solidFill>
-                  <a:srgbClr val="404040"/>
-                </a:solidFill>
-              </a:defRPr>
-            </a:pPr>
-            <a:r>
-              <a:t>• 80% reduction in assessment time (1 hour vs 5-7 days)</a:t>
-            </a:r>
-          </a:p>
-          <a:p>
-            <a:pPr lvl="1">
-              <a:spcBef>
-                <a:spcPts val="400"/>
-              </a:spcBef>
-              <a:spcAft>
-                <a:spcPts val="400"/>
-              </a:spcAft>
-              <a:defRPr sz="1400">
-                <a:solidFill>
-                  <a:srgbClr val="404040"/>
-                </a:solidFill>
-              </a:defRPr>
-            </a:pPr>
-            <a:r>
-              <a:t>• 60% cost reduction per claim</a:t>
-            </a:r>
-          </a:p>
-          <a:p>
-            <a:pPr lvl="1">
-              <a:spcBef>
-                <a:spcPts val="400"/>
-              </a:spcBef>
-              <a:spcAft>
-                <a:spcPts val="400"/>
-              </a:spcAft>
-              <a:defRPr sz="1400">
-                <a:solidFill>
-                  <a:srgbClr val="404040"/>
-                </a:solidFill>
-              </a:defRPr>
-            </a:pPr>
-            <a:r>
-              <a:t>• 3x throughput increase</a:t>
-            </a:r>
-          </a:p>
-          <a:p>
-            <a:pPr lvl="1">
-              <a:spcBef>
-                <a:spcPts val="400"/>
-              </a:spcBef>
-              <a:spcAft>
-                <a:spcPts val="400"/>
-              </a:spcAft>
-              <a:defRPr sz="1400">
-                <a:solidFill>
-                  <a:srgbClr val="404040"/>
-                </a:solidFill>
-              </a:defRPr>
-            </a:pPr>
-            <a:r>
-              <a:t>🛡️ Risk &amp; Compliance</a:t>
-            </a:r>
-          </a:p>
-          <a:p>
-            <a:pPr lvl="1">
-              <a:spcBef>
-                <a:spcPts val="400"/>
-              </a:spcBef>
-              <a:spcAft>
-                <a:spcPts val="400"/>
-              </a:spcAft>
-              <a:defRPr sz="1400">
-                <a:solidFill>
-                  <a:srgbClr val="404040"/>
-                </a:solidFill>
-              </a:defRPr>
-            </a:pPr>
-            <a:r>
-              <a:t>• Fraud detection accuracy: 94.7%</a:t>
-            </a:r>
-          </a:p>
-          <a:p>
-            <a:pPr lvl="1">
-              <a:spcBef>
-                <a:spcPts val="400"/>
-              </a:spcBef>
-              <a:spcAft>
-                <a:spcPts val="400"/>
-              </a:spcAft>
-              <a:defRPr sz="1400">
-                <a:solidFill>
-                  <a:srgbClr val="404040"/>
-                </a:solidFill>
-              </a:defRPr>
-            </a:pPr>
-            <a:r>
-              <a:t>• 100% regulatory compliance coverage</a:t>
-            </a:r>
-          </a:p>
-          <a:p>
-            <a:pPr lvl="1">
-              <a:spcBef>
-                <a:spcPts val="400"/>
-              </a:spcBef>
-              <a:spcAft>
-                <a:spcPts val="400"/>
-              </a:spcAft>
-              <a:defRPr sz="1400">
-                <a:solidFill>
-                  <a:srgbClr val="404040"/>
-                </a:solidFill>
-              </a:defRPr>
-            </a:pPr>
-            <a:r>
-              <a:t>• Zero compliance violations in testing</a:t>
-            </a:r>
-          </a:p>
-          <a:p>
-            <a:pPr lvl="1">
-              <a:spcBef>
-                <a:spcPts val="400"/>
-              </a:spcBef>
-              <a:spcAft>
-                <a:spcPts val="400"/>
-              </a:spcAft>
-              <a:defRPr sz="1400">
-                <a:solidFill>
-                  <a:srgbClr val="404040"/>
-                </a:solidFill>
-              </a:defRPr>
-            </a:pPr>
-            <a:r>
-              <a:t>👥 Customer Experience</a:t>
-            </a:r>
-          </a:p>
-          <a:p>
-            <a:pPr lvl="1">
-              <a:spcBef>
-                <a:spcPts val="400"/>
-              </a:spcBef>
-              <a:spcAft>
-                <a:spcPts val="400"/>
-              </a:spcAft>
-              <a:defRPr sz="1400">
-                <a:solidFill>
-                  <a:srgbClr val="404040"/>
-                </a:solidFill>
-              </a:defRPr>
-            </a:pPr>
-            <a:r>
-              <a:t>• Real-time claim status tracking</a:t>
-            </a:r>
-          </a:p>
-          <a:p>
-            <a:pPr lvl="1">
-              <a:spcBef>
-                <a:spcPts val="400"/>
-              </a:spcBef>
-              <a:spcAft>
-                <a:spcPts val="400"/>
-              </a:spcAft>
-              <a:defRPr sz="1400">
-                <a:solidFill>
-                  <a:srgbClr val="404040"/>
-                </a:solidFill>
-              </a:defRPr>
-            </a:pPr>
-            <a:r>
-              <a:t>• Faster claim settlements</a:t>
-            </a:r>
-          </a:p>
-          <a:p>
-            <a:pPr lvl="1">
-              <a:spcBef>
-                <a:spcPts val="400"/>
-              </a:spcBef>
-              <a:spcAft>
-                <a:spcPts val="400"/>
-              </a:spcAft>
-              <a:defRPr sz="1400">
-                <a:solidFill>
-                  <a:srgbClr val="404040"/>
-                </a:solidFill>
-              </a:defRPr>
-            </a:pPr>
-            <a:r>
-              <a:t>• Transparent decision explanations</a:t>
+              <a:t>✓ Autonomous AI Assessment Pipeline</a:t>
+            </a:r>
+          </a:p>
+          <a:p>
+            <a:pPr lvl="1">
+              <a:spcBef>
+                <a:spcPts val="400"/>
+              </a:spcBef>
+              <a:spcAft>
+                <a:spcPts val="400"/>
+              </a:spcAft>
+              <a:defRPr sz="1400">
+                <a:solidFill>
+                  <a:srgbClr val="404040"/>
+                </a:solidFill>
+              </a:defRPr>
+            </a:pPr>
+            <a:r>
+              <a:t>- End-to-end claim processing without human intervention</a:t>
+            </a:r>
+          </a:p>
+          <a:p>
+            <a:pPr lvl="1">
+              <a:spcBef>
+                <a:spcPts val="400"/>
+              </a:spcBef>
+              <a:spcAft>
+                <a:spcPts val="400"/>
+              </a:spcAft>
+              <a:defRPr sz="1400">
+                <a:solidFill>
+                  <a:srgbClr val="404040"/>
+                </a:solidFill>
+              </a:defRPr>
+            </a:pPr>
+            <a:r>
+              <a:t>✓ Multi-Agent Architecture</a:t>
+            </a:r>
+          </a:p>
+          <a:p>
+            <a:pPr lvl="1">
+              <a:spcBef>
+                <a:spcPts val="400"/>
+              </a:spcBef>
+              <a:spcAft>
+                <a:spcPts val="400"/>
+              </a:spcAft>
+              <a:defRPr sz="1400">
+                <a:solidFill>
+                  <a:srgbClr val="404040"/>
+                </a:solidFill>
+              </a:defRPr>
+            </a:pPr>
+            <a:r>
+              <a:t>- 6 specialized agents for different claim assessment aspects</a:t>
+            </a:r>
+          </a:p>
+          <a:p>
+            <a:pPr lvl="1">
+              <a:spcBef>
+                <a:spcPts val="400"/>
+              </a:spcBef>
+              <a:spcAft>
+                <a:spcPts val="400"/>
+              </a:spcAft>
+              <a:defRPr sz="1400">
+                <a:solidFill>
+                  <a:srgbClr val="404040"/>
+                </a:solidFill>
+              </a:defRPr>
+            </a:pPr>
+            <a:r>
+              <a:t>- Fraud detection, compliance validation, risk scoring</a:t>
+            </a:r>
+          </a:p>
+          <a:p>
+            <a:pPr lvl="1">
+              <a:spcBef>
+                <a:spcPts val="400"/>
+              </a:spcBef>
+              <a:spcAft>
+                <a:spcPts val="400"/>
+              </a:spcAft>
+              <a:defRPr sz="1400">
+                <a:solidFill>
+                  <a:srgbClr val="404040"/>
+                </a:solidFill>
+              </a:defRPr>
+            </a:pPr>
+            <a:r>
+              <a:t>✓ Full Regulatory Compliance</a:t>
+            </a:r>
+          </a:p>
+          <a:p>
+            <a:pPr lvl="1">
+              <a:spcBef>
+                <a:spcPts val="400"/>
+              </a:spcBef>
+              <a:spcAft>
+                <a:spcPts val="400"/>
+              </a:spcAft>
+              <a:defRPr sz="1400">
+                <a:solidFill>
+                  <a:srgbClr val="404040"/>
+                </a:solidFill>
+              </a:defRPr>
+            </a:pPr>
+            <a:r>
+              <a:t>- IRDAI, SOX, AML regulation enforcement</a:t>
+            </a:r>
+          </a:p>
+          <a:p>
+            <a:pPr lvl="1">
+              <a:spcBef>
+                <a:spcPts val="400"/>
+              </a:spcBef>
+              <a:spcAft>
+                <a:spcPts val="400"/>
+              </a:spcAft>
+              <a:defRPr sz="1400">
+                <a:solidFill>
+                  <a:srgbClr val="404040"/>
+                </a:solidFill>
+              </a:defRPr>
+            </a:pPr>
+            <a:r>
+              <a:t>- Immutable audit trails for all decisions</a:t>
+            </a:r>
+          </a:p>
+          <a:p>
+            <a:pPr lvl="1">
+              <a:spcBef>
+                <a:spcPts val="400"/>
+              </a:spcBef>
+              <a:spcAft>
+                <a:spcPts val="400"/>
+              </a:spcAft>
+              <a:defRPr sz="1400">
+                <a:solidFill>
+                  <a:srgbClr val="404040"/>
+                </a:solidFill>
+              </a:defRPr>
+            </a:pPr>
+            <a:r>
+              <a:t>✓ Complete Traceability</a:t>
+            </a:r>
+          </a:p>
+          <a:p>
+            <a:pPr lvl="1">
+              <a:spcBef>
+                <a:spcPts val="400"/>
+              </a:spcBef>
+              <a:spcAft>
+                <a:spcPts val="400"/>
+              </a:spcAft>
+              <a:defRPr sz="1400">
+                <a:solidFill>
+                  <a:srgbClr val="404040"/>
+                </a:solidFill>
+              </a:defRPr>
+            </a:pPr>
+            <a:r>
+              <a:t>- Chain-of-thought reasoning for every decision</a:t>
+            </a:r>
+          </a:p>
+          <a:p>
+            <a:pPr lvl="1">
+              <a:spcBef>
+                <a:spcPts val="400"/>
+              </a:spcBef>
+              <a:spcAft>
+                <a:spcPts val="400"/>
+              </a:spcAft>
+              <a:defRPr sz="1400">
+                <a:solidFill>
+                  <a:srgbClr val="404040"/>
+                </a:solidFill>
+              </a:defRPr>
+            </a:pPr>
+            <a:r>
+              <a:t>- Explainable AI with confidence scores</a:t>
             </a:r>
           </a:p>
         </p:txBody>
@@ -12230,7 +10990,7 @@
 </p:sld>
 </file>
 
-<file path=ppt/slides/slide5.xml><?xml version="1.0" encoding="utf-8"?>
+<file path=ppt/slides/slide4.xml><?xml version="1.0" encoding="utf-8"?>
 <p:sld xmlns:a="http://schemas.openxmlformats.org/drawingml/2006/main" xmlns:p="http://schemas.openxmlformats.org/presentationml/2006/main" xmlns:r="http://schemas.openxmlformats.org/officeDocument/2006/relationships">
   <p:cSld>
     <p:bg>
@@ -12323,6 +11083,352 @@
               </a:defRPr>
             </a:pPr>
             <a:r>
+              <a:t>Slide 4: Key Business Benefits</a:t>
+            </a:r>
+          </a:p>
+        </p:txBody>
+      </p:sp>
+      <p:sp>
+        <p:nvSpPr>
+          <p:cNvPr id="4" name="TextBox 3"/>
+          <p:cNvSpPr txBox="1"/>
+          <p:nvPr/>
+        </p:nvSpPr>
+        <p:spPr>
+          <a:xfrm>
+            <a:off x="640080" y="1097280"/>
+            <a:ext cx="7863840" cy="5303520"/>
+          </a:xfrm>
+          <a:prstGeom prst="rect">
+            <a:avLst/>
+          </a:prstGeom>
+          <a:noFill/>
+        </p:spPr>
+        <p:txBody>
+          <a:bodyPr wrap="square">
+            <a:spAutoFit/>
+          </a:bodyPr>
+          <a:lstStyle/>
+          <a:p/>
+          <a:p>
+            <a:pPr>
+              <a:spcBef>
+                <a:spcPts val="400"/>
+              </a:spcBef>
+              <a:spcAft>
+                <a:spcPts val="400"/>
+              </a:spcAft>
+              <a:defRPr sz="1400">
+                <a:solidFill>
+                  <a:srgbClr val="404040"/>
+                </a:solidFill>
+              </a:defRPr>
+            </a:pPr>
+            <a:r>
+              <a:t>📈 Operational Impact</a:t>
+            </a:r>
+          </a:p>
+          <a:p>
+            <a:pPr lvl="1">
+              <a:spcBef>
+                <a:spcPts val="400"/>
+              </a:spcBef>
+              <a:spcAft>
+                <a:spcPts val="400"/>
+              </a:spcAft>
+              <a:defRPr sz="1400">
+                <a:solidFill>
+                  <a:srgbClr val="404040"/>
+                </a:solidFill>
+              </a:defRPr>
+            </a:pPr>
+            <a:r>
+              <a:t>• 80% reduction in assessment time (1 hour vs 5-7 days)</a:t>
+            </a:r>
+          </a:p>
+          <a:p>
+            <a:pPr lvl="1">
+              <a:spcBef>
+                <a:spcPts val="400"/>
+              </a:spcBef>
+              <a:spcAft>
+                <a:spcPts val="400"/>
+              </a:spcAft>
+              <a:defRPr sz="1400">
+                <a:solidFill>
+                  <a:srgbClr val="404040"/>
+                </a:solidFill>
+              </a:defRPr>
+            </a:pPr>
+            <a:r>
+              <a:t>• 60% cost reduction per claim</a:t>
+            </a:r>
+          </a:p>
+          <a:p>
+            <a:pPr lvl="1">
+              <a:spcBef>
+                <a:spcPts val="400"/>
+              </a:spcBef>
+              <a:spcAft>
+                <a:spcPts val="400"/>
+              </a:spcAft>
+              <a:defRPr sz="1400">
+                <a:solidFill>
+                  <a:srgbClr val="404040"/>
+                </a:solidFill>
+              </a:defRPr>
+            </a:pPr>
+            <a:r>
+              <a:t>• 3x throughput increase</a:t>
+            </a:r>
+          </a:p>
+          <a:p>
+            <a:pPr lvl="1">
+              <a:spcBef>
+                <a:spcPts val="400"/>
+              </a:spcBef>
+              <a:spcAft>
+                <a:spcPts val="400"/>
+              </a:spcAft>
+              <a:defRPr sz="1400">
+                <a:solidFill>
+                  <a:srgbClr val="404040"/>
+                </a:solidFill>
+              </a:defRPr>
+            </a:pPr>
+            <a:r>
+              <a:t>🛡️ Risk &amp; Compliance</a:t>
+            </a:r>
+          </a:p>
+          <a:p>
+            <a:pPr lvl="1">
+              <a:spcBef>
+                <a:spcPts val="400"/>
+              </a:spcBef>
+              <a:spcAft>
+                <a:spcPts val="400"/>
+              </a:spcAft>
+              <a:defRPr sz="1400">
+                <a:solidFill>
+                  <a:srgbClr val="404040"/>
+                </a:solidFill>
+              </a:defRPr>
+            </a:pPr>
+            <a:r>
+              <a:t>• Fraud detection accuracy: 94.7%</a:t>
+            </a:r>
+          </a:p>
+          <a:p>
+            <a:pPr lvl="1">
+              <a:spcBef>
+                <a:spcPts val="400"/>
+              </a:spcBef>
+              <a:spcAft>
+                <a:spcPts val="400"/>
+              </a:spcAft>
+              <a:defRPr sz="1400">
+                <a:solidFill>
+                  <a:srgbClr val="404040"/>
+                </a:solidFill>
+              </a:defRPr>
+            </a:pPr>
+            <a:r>
+              <a:t>• 100% regulatory compliance coverage</a:t>
+            </a:r>
+          </a:p>
+          <a:p>
+            <a:pPr lvl="1">
+              <a:spcBef>
+                <a:spcPts val="400"/>
+              </a:spcBef>
+              <a:spcAft>
+                <a:spcPts val="400"/>
+              </a:spcAft>
+              <a:defRPr sz="1400">
+                <a:solidFill>
+                  <a:srgbClr val="404040"/>
+                </a:solidFill>
+              </a:defRPr>
+            </a:pPr>
+            <a:r>
+              <a:t>• Zero compliance violations in testing</a:t>
+            </a:r>
+          </a:p>
+          <a:p>
+            <a:pPr lvl="1">
+              <a:spcBef>
+                <a:spcPts val="400"/>
+              </a:spcBef>
+              <a:spcAft>
+                <a:spcPts val="400"/>
+              </a:spcAft>
+              <a:defRPr sz="1400">
+                <a:solidFill>
+                  <a:srgbClr val="404040"/>
+                </a:solidFill>
+              </a:defRPr>
+            </a:pPr>
+            <a:r>
+              <a:t>👥 Customer Experience</a:t>
+            </a:r>
+          </a:p>
+          <a:p>
+            <a:pPr lvl="1">
+              <a:spcBef>
+                <a:spcPts val="400"/>
+              </a:spcBef>
+              <a:spcAft>
+                <a:spcPts val="400"/>
+              </a:spcAft>
+              <a:defRPr sz="1400">
+                <a:solidFill>
+                  <a:srgbClr val="404040"/>
+                </a:solidFill>
+              </a:defRPr>
+            </a:pPr>
+            <a:r>
+              <a:t>• Real-time claim status tracking</a:t>
+            </a:r>
+          </a:p>
+          <a:p>
+            <a:pPr lvl="1">
+              <a:spcBef>
+                <a:spcPts val="400"/>
+              </a:spcBef>
+              <a:spcAft>
+                <a:spcPts val="400"/>
+              </a:spcAft>
+              <a:defRPr sz="1400">
+                <a:solidFill>
+                  <a:srgbClr val="404040"/>
+                </a:solidFill>
+              </a:defRPr>
+            </a:pPr>
+            <a:r>
+              <a:t>• Faster claim settlements</a:t>
+            </a:r>
+          </a:p>
+          <a:p>
+            <a:pPr lvl="1">
+              <a:spcBef>
+                <a:spcPts val="400"/>
+              </a:spcBef>
+              <a:spcAft>
+                <a:spcPts val="400"/>
+              </a:spcAft>
+              <a:defRPr sz="1400">
+                <a:solidFill>
+                  <a:srgbClr val="404040"/>
+                </a:solidFill>
+              </a:defRPr>
+            </a:pPr>
+            <a:r>
+              <a:t>• Transparent decision explanations</a:t>
+            </a:r>
+          </a:p>
+        </p:txBody>
+      </p:sp>
+    </p:spTree>
+  </p:cSld>
+  <p:clrMapOvr>
+    <a:masterClrMapping/>
+  </p:clrMapOvr>
+</p:sld>
+</file>
+
+<file path=ppt/slides/slide5.xml><?xml version="1.0" encoding="utf-8"?>
+<p:sld xmlns:a="http://schemas.openxmlformats.org/drawingml/2006/main" xmlns:p="http://schemas.openxmlformats.org/presentationml/2006/main" xmlns:r="http://schemas.openxmlformats.org/officeDocument/2006/relationships">
+  <p:cSld>
+    <p:bg>
+      <p:bgPr>
+        <a:solidFill>
+          <a:srgbClr val="FFFFFF"/>
+        </a:solidFill>
+        <a:effectLst/>
+      </p:bgPr>
+    </p:bg>
+    <p:spTree>
+      <p:nvGrpSpPr>
+        <p:cNvPr id="1" name=""/>
+        <p:cNvGrpSpPr/>
+        <p:nvPr/>
+      </p:nvGrpSpPr>
+      <p:grpSpPr/>
+      <p:sp>
+        <p:nvSpPr>
+          <p:cNvPr id="2" name="Rectangle 1"/>
+          <p:cNvSpPr/>
+          <p:nvPr/>
+        </p:nvSpPr>
+        <p:spPr>
+          <a:xfrm>
+            <a:off x="0" y="0"/>
+            <a:ext cx="9144000" cy="731520"/>
+          </a:xfrm>
+          <a:prstGeom prst="rect">
+            <a:avLst/>
+          </a:prstGeom>
+          <a:solidFill>
+            <a:srgbClr val="19376D"/>
+          </a:solidFill>
+          <a:ln>
+            <a:solidFill>
+              <a:srgbClr val="19376D"/>
+            </a:solidFill>
+          </a:ln>
+        </p:spPr>
+        <p:style>
+          <a:lnRef idx="1">
+            <a:schemeClr val="accent1"/>
+          </a:lnRef>
+          <a:fillRef idx="3">
+            <a:schemeClr val="accent1"/>
+          </a:fillRef>
+          <a:effectRef idx="2">
+            <a:schemeClr val="accent1"/>
+          </a:effectRef>
+          <a:fontRef idx="minor">
+            <a:schemeClr val="lt1"/>
+          </a:fontRef>
+        </p:style>
+        <p:txBody>
+          <a:bodyPr rtlCol="0" anchor="ctr"/>
+          <a:lstStyle/>
+          <a:p>
+            <a:pPr algn="ctr"/>
+          </a:p>
+        </p:txBody>
+      </p:sp>
+      <p:sp>
+        <p:nvSpPr>
+          <p:cNvPr id="3" name="TextBox 2"/>
+          <p:cNvSpPr txBox="1"/>
+          <p:nvPr/>
+        </p:nvSpPr>
+        <p:spPr>
+          <a:xfrm>
+            <a:off x="457200" y="137160"/>
+            <a:ext cx="8229600" cy="548640"/>
+          </a:xfrm>
+          <a:prstGeom prst="rect">
+            <a:avLst/>
+          </a:prstGeom>
+          <a:noFill/>
+        </p:spPr>
+        <p:txBody>
+          <a:bodyPr wrap="square">
+            <a:spAutoFit/>
+          </a:bodyPr>
+          <a:lstStyle/>
+          <a:p>
+            <a:pPr>
+              <a:defRPr sz="3200" b="1">
+                <a:solidFill>
+                  <a:srgbClr val="FFFFFF"/>
+                </a:solidFill>
+              </a:defRPr>
+            </a:pPr>
+            <a:r>
               <a:t>Slide 5: Agent Architecture</a:t>
             </a:r>
           </a:p>
@@ -12642,91 +11748,35 @@
               </a:defRPr>
             </a:pPr>
             <a:r>
-              <a:t>Slide 6: Processing Pipeline Flow</a:t>
-            </a:r>
-          </a:p>
-        </p:txBody>
-      </p:sp>
-      <p:sp>
-        <p:nvSpPr>
-          <p:cNvPr id="3" name="TextBox 2"/>
-          <p:cNvSpPr txBox="1"/>
+              <a:t>Slide 6: Dashboard - Real Application Interface</a:t>
+            </a:r>
+          </a:p>
+        </p:txBody>
+      </p:sp>
+      <p:pic>
+        <p:nvPicPr>
+          <p:cNvPr id="3" name="Picture 2" descr="screenshot_dashboard.png"/>
+          <p:cNvPicPr>
+            <a:picLocks noChangeAspect="1"/>
+          </p:cNvPicPr>
           <p:nvPr/>
-        </p:nvSpPr>
+        </p:nvPicPr>
+        <p:blipFill>
+          <a:blip r:embed="rId2"/>
+          <a:stretch>
+            <a:fillRect/>
+          </a:stretch>
+        </p:blipFill>
         <p:spPr>
           <a:xfrm>
-            <a:off x="457200" y="1371600"/>
-            <a:ext cx="8229600" cy="5029200"/>
+            <a:off x="274320" y="1097280"/>
+            <a:ext cx="8595360" cy="6446520"/>
           </a:xfrm>
           <a:prstGeom prst="rect">
             <a:avLst/>
           </a:prstGeom>
-          <a:noFill/>
         </p:spPr>
-        <p:txBody>
-          <a:bodyPr wrap="square">
-            <a:spAutoFit/>
-          </a:bodyPr>
-          <a:lstStyle/>
-          <a:p>
-            <a:br/>
-            <a:pPr>
-              <a:defRPr sz="1400" b="0">
-                <a:solidFill>
-                  <a:srgbClr val="404040"/>
-                </a:solidFill>
-              </a:defRPr>
-            </a:pPr>
-            <a:r>
-              <a:t>    INPUT → [InputValidationHook] → [SecurityHook]</a:t>
-            </a:r>
-            <a:br/>
-            <a:r>
-              <a:t>              ↓</a:t>
-            </a:r>
-            <a:br/>
-            <a:r>
-              <a:t>    [CustomerAgent] → [KnowledgeAgent with MCP]</a:t>
-            </a:r>
-            <a:br/>
-            <a:r>
-              <a:t>              ↓</a:t>
-            </a:r>
-            <a:br/>
-            <a:r>
-              <a:t>    [ComplianceAgent] ⟷ [RiskAgent] (parallel)</a:t>
-            </a:r>
-            <a:br/>
-            <a:r>
-              <a:t>              ↓</a:t>
-            </a:r>
-            <a:br/>
-            <a:r>
-              <a:t>    [DecisionAgent] → [AuditAgent]</a:t>
-            </a:r>
-            <a:br/>
-            <a:r>
-              <a:t>              ↓</a:t>
-            </a:r>
-            <a:br/>
-            <a:r>
-              <a:t>    [GovernanceHook] → [OutputValidationHook]</a:t>
-            </a:r>
-            <a:br/>
-            <a:r>
-              <a:t>              ↓</a:t>
-            </a:r>
-            <a:br/>
-            <a:r>
-              <a:t>    RESPONSE (Decision + Audit Trail + Confidence Score)</a:t>
-            </a:r>
-            <a:br/>
-            <a:r>
-              <a:t>    </a:t>
-            </a:r>
-          </a:p>
-        </p:txBody>
-      </p:sp>
+      </p:pic>
     </p:spTree>
   </p:cSld>
   <p:clrMapOvr>

</xml_diff>